<commit_message>
Big day of recordings and updating lectures + resoliving 1st issues picked out by Vicki
</commit_message>
<xml_diff>
--- a/Lectures/Lecture 05.1 LM with categorical.pptx
+++ b/Lectures/Lecture 05.1 LM with categorical.pptx
@@ -5,7 +5,7 @@
     <p:sldMasterId id="2147483660" r:id="rId1"/>
   </p:sldMasterIdLst>
   <p:notesMasterIdLst>
-    <p:notesMasterId r:id="rId30"/>
+    <p:notesMasterId r:id="rId31"/>
   </p:notesMasterIdLst>
   <p:sldIdLst>
     <p:sldId id="257" r:id="rId2"/>
@@ -26,16 +26,17 @@
     <p:sldId id="323" r:id="rId17"/>
     <p:sldId id="287" r:id="rId18"/>
     <p:sldId id="288" r:id="rId19"/>
-    <p:sldId id="327" r:id="rId20"/>
-    <p:sldId id="329" r:id="rId21"/>
-    <p:sldId id="331" r:id="rId22"/>
-    <p:sldId id="333" r:id="rId23"/>
-    <p:sldId id="334" r:id="rId24"/>
-    <p:sldId id="335" r:id="rId25"/>
-    <p:sldId id="332" r:id="rId26"/>
-    <p:sldId id="320" r:id="rId27"/>
-    <p:sldId id="330" r:id="rId28"/>
-    <p:sldId id="302" r:id="rId29"/>
+    <p:sldId id="336" r:id="rId20"/>
+    <p:sldId id="327" r:id="rId21"/>
+    <p:sldId id="329" r:id="rId22"/>
+    <p:sldId id="331" r:id="rId23"/>
+    <p:sldId id="333" r:id="rId24"/>
+    <p:sldId id="334" r:id="rId25"/>
+    <p:sldId id="335" r:id="rId26"/>
+    <p:sldId id="332" r:id="rId27"/>
+    <p:sldId id="320" r:id="rId28"/>
+    <p:sldId id="330" r:id="rId29"/>
+    <p:sldId id="302" r:id="rId30"/>
   </p:sldIdLst>
   <p:sldSz cx="12192000" cy="6858000"/>
   <p:notesSz cx="6858000" cy="9144000"/>
@@ -224,7 +225,7 @@
           <a:p>
             <a:fld id="{19306761-C467-451A-B631-B83A8FB7E2AD}" type="datetimeFigureOut">
               <a:rPr lang="en-GB" smtClean="0"/>
-              <a:t>29/07/2024</a:t>
+              <a:t>06/09/2024</a:t>
             </a:fld>
             <a:endParaRPr lang="en-GB"/>
           </a:p>
@@ -557,7 +558,7 @@
           <a:p>
             <a:fld id="{80DA05D5-BE59-48F1-821C-F6C56F891EAA}" type="slidenum">
               <a:rPr lang="en-GB" smtClean="0"/>
-              <a:t>25</a:t>
+              <a:t>26</a:t>
             </a:fld>
             <a:endParaRPr lang="en-GB"/>
           </a:p>
@@ -641,7 +642,7 @@
           <a:p>
             <a:fld id="{80DA05D5-BE59-48F1-821C-F6C56F891EAA}" type="slidenum">
               <a:rPr lang="en-GB" smtClean="0"/>
-              <a:t>27</a:t>
+              <a:t>28</a:t>
             </a:fld>
             <a:endParaRPr lang="en-GB"/>
           </a:p>
@@ -1001,7 +1002,7 @@
           <a:p>
             <a:fld id="{7EE9FA64-2165-4ED8-BB13-AC16E72ED8FC}" type="datetimeFigureOut">
               <a:rPr lang="en-GB" smtClean="0"/>
-              <a:t>29/07/2024</a:t>
+              <a:t>06/09/2024</a:t>
             </a:fld>
             <a:endParaRPr lang="en-GB"/>
           </a:p>
@@ -1211,7 +1212,7 @@
           <a:p>
             <a:fld id="{7EE9FA64-2165-4ED8-BB13-AC16E72ED8FC}" type="datetimeFigureOut">
               <a:rPr lang="en-GB" smtClean="0"/>
-              <a:t>29/07/2024</a:t>
+              <a:t>06/09/2024</a:t>
             </a:fld>
             <a:endParaRPr lang="en-GB"/>
           </a:p>
@@ -1433,7 +1434,7 @@
           <a:p>
             <a:fld id="{7EE9FA64-2165-4ED8-BB13-AC16E72ED8FC}" type="datetimeFigureOut">
               <a:rPr lang="en-GB" smtClean="0"/>
-              <a:t>29/07/2024</a:t>
+              <a:t>06/09/2024</a:t>
             </a:fld>
             <a:endParaRPr lang="en-GB"/>
           </a:p>
@@ -1615,7 +1616,7 @@
           <a:p>
             <a:fld id="{A5C66AAF-4858-49E9-B86B-FBFED3DD34F6}" type="datetimeFigureOut">
               <a:rPr lang="en-GB" smtClean="0"/>
-              <a:t>29/07/2024</a:t>
+              <a:t>06/09/2024</a:t>
             </a:fld>
             <a:endParaRPr lang="en-GB"/>
           </a:p>
@@ -2542,7 +2543,7 @@
           <a:p>
             <a:fld id="{7EE9FA64-2165-4ED8-BB13-AC16E72ED8FC}" type="datetimeFigureOut">
               <a:rPr lang="en-GB" smtClean="0"/>
-              <a:t>29/07/2024</a:t>
+              <a:t>06/09/2024</a:t>
             </a:fld>
             <a:endParaRPr lang="en-GB"/>
           </a:p>
@@ -2684,7 +2685,7 @@
           <a:p>
             <a:fld id="{7EE9FA64-2165-4ED8-BB13-AC16E72ED8FC}" type="datetimeFigureOut">
               <a:rPr lang="en-GB" smtClean="0"/>
-              <a:t>29/07/2024</a:t>
+              <a:t>06/09/2024</a:t>
             </a:fld>
             <a:endParaRPr lang="en-GB"/>
           </a:p>
@@ -2797,7 +2798,7 @@
           <a:p>
             <a:fld id="{7EE9FA64-2165-4ED8-BB13-AC16E72ED8FC}" type="datetimeFigureOut">
               <a:rPr lang="en-GB" smtClean="0"/>
-              <a:t>29/07/2024</a:t>
+              <a:t>06/09/2024</a:t>
             </a:fld>
             <a:endParaRPr lang="en-GB"/>
           </a:p>
@@ -3110,7 +3111,7 @@
           <a:p>
             <a:fld id="{7EE9FA64-2165-4ED8-BB13-AC16E72ED8FC}" type="datetimeFigureOut">
               <a:rPr lang="en-GB" smtClean="0"/>
-              <a:t>29/07/2024</a:t>
+              <a:t>06/09/2024</a:t>
             </a:fld>
             <a:endParaRPr lang="en-GB"/>
           </a:p>
@@ -3403,7 +3404,7 @@
           <a:p>
             <a:fld id="{7EE9FA64-2165-4ED8-BB13-AC16E72ED8FC}" type="datetimeFigureOut">
               <a:rPr lang="en-GB" smtClean="0"/>
-              <a:t>29/07/2024</a:t>
+              <a:t>06/09/2024</a:t>
             </a:fld>
             <a:endParaRPr lang="en-GB"/>
           </a:p>
@@ -3646,7 +3647,7 @@
           <a:p>
             <a:fld id="{7EE9FA64-2165-4ED8-BB13-AC16E72ED8FC}" type="datetimeFigureOut">
               <a:rPr lang="en-GB" smtClean="0"/>
-              <a:t>29/07/2024</a:t>
+              <a:t>06/09/2024</a:t>
             </a:fld>
             <a:endParaRPr lang="en-GB"/>
           </a:p>
@@ -10272,8 +10273,8 @@
           </a:p>
         </p:txBody>
       </p:sp>
-      <mc:AlternateContent xmlns:mc="http://schemas.openxmlformats.org/markup-compatibility/2006" xmlns:a14="http://schemas.microsoft.com/office/drawing/2010/main">
-        <mc:Choice Requires="a14">
+      <mc:AlternateContent xmlns:mc="http://schemas.openxmlformats.org/markup-compatibility/2006">
+        <mc:Choice xmlns:a14="http://schemas.microsoft.com/office/drawing/2010/main" Requires="a14">
           <p:sp>
             <p:nvSpPr>
               <p:cNvPr id="3" name="Content Placeholder 2">
@@ -10292,7 +10293,9 @@
             </p:nvSpPr>
             <p:spPr/>
             <p:txBody>
-              <a:bodyPr/>
+              <a:bodyPr>
+                <a:normAutofit lnSpcReduction="10000"/>
+              </a:bodyPr>
               <a:lstStyle/>
               <a:p>
                 <a14:m>
@@ -10372,6 +10375,13 @@
                 </a:r>
               </a:p>
               <a:p>
+                <a:pPr lvl="1"/>
+                <a:r>
+                  <a:rPr lang="en-GB" dirty="0"/>
+                  <a:t>E.g. Peace sheep horns are 100 mm long, and Skeena are 300 mm (in this example).</a:t>
+                </a:r>
+              </a:p>
+              <a:p>
                 <a:r>
                   <a:rPr lang="en-GB" dirty="0"/>
                   <a:t>No limit to the number of groups you can have</a:t>
@@ -10380,7 +10390,7 @@
               <a:p>
                 <a:r>
                   <a:rPr lang="en-GB" dirty="0"/>
-                  <a:t>Each parameter is always the </a:t>
+                  <a:t>Each subsequent group is always the </a:t>
                 </a:r>
                 <a:r>
                   <a:rPr lang="en-GB" i="1" dirty="0"/>
@@ -10388,13 +10398,13 @@
                 </a:r>
                 <a:r>
                   <a:rPr lang="en-GB" dirty="0"/>
-                  <a:t> to the intercept</a:t>
+                  <a:t> from the reference (i.e. the intercept)</a:t>
                 </a:r>
               </a:p>
             </p:txBody>
           </p:sp>
         </mc:Choice>
-        <mc:Fallback xmlns="">
+        <mc:Fallback>
           <p:sp>
             <p:nvSpPr>
               <p:cNvPr id="3" name="Content Placeholder 2">
@@ -10415,7 +10425,7 @@
               <a:blipFill>
                 <a:blip r:embed="rId2"/>
                 <a:stretch>
-                  <a:fillRect l="-1770"/>
+                  <a:fillRect l="-1770" t="-2558" b="-2558"/>
                 </a:stretch>
               </a:blipFill>
             </p:spPr>
@@ -12150,76 +12160,6 @@
                                   </p:childTnLst>
                                 </p:cTn>
                               </p:par>
-                              <p:par>
-                                <p:cTn id="31" presetID="10" presetClass="entr" presetSubtype="0" fill="hold" nodeType="withEffect">
-                                  <p:stCondLst>
-                                    <p:cond delay="0"/>
-                                  </p:stCondLst>
-                                  <p:childTnLst>
-                                    <p:set>
-                                      <p:cBhvr>
-                                        <p:cTn id="32" dur="1" fill="hold">
-                                          <p:stCondLst>
-                                            <p:cond delay="0"/>
-                                          </p:stCondLst>
-                                        </p:cTn>
-                                        <p:tgtEl>
-                                          <p:spTgt spid="15"/>
-                                        </p:tgtEl>
-                                        <p:attrNameLst>
-                                          <p:attrName>style.visibility</p:attrName>
-                                        </p:attrNameLst>
-                                      </p:cBhvr>
-                                      <p:to>
-                                        <p:strVal val="visible"/>
-                                      </p:to>
-                                    </p:set>
-                                    <p:animEffect transition="in" filter="fade">
-                                      <p:cBhvr>
-                                        <p:cTn id="33" dur="500"/>
-                                        <p:tgtEl>
-                                          <p:spTgt spid="15"/>
-                                        </p:tgtEl>
-                                      </p:cBhvr>
-                                    </p:animEffect>
-                                  </p:childTnLst>
-                                </p:cTn>
-                              </p:par>
-                              <p:par>
-                                <p:cTn id="34" presetID="10" presetClass="exit" presetSubtype="0" fill="hold" nodeType="withEffect">
-                                  <p:stCondLst>
-                                    <p:cond delay="0"/>
-                                  </p:stCondLst>
-                                  <p:childTnLst>
-                                    <p:animEffect transition="out" filter="fade">
-                                      <p:cBhvr>
-                                        <p:cTn id="35" dur="500"/>
-                                        <p:tgtEl>
-                                          <p:spTgt spid="6"/>
-                                        </p:tgtEl>
-                                      </p:cBhvr>
-                                    </p:animEffect>
-                                    <p:set>
-                                      <p:cBhvr>
-                                        <p:cTn id="36" dur="1" fill="hold">
-                                          <p:stCondLst>
-                                            <p:cond delay="499"/>
-                                          </p:stCondLst>
-                                        </p:cTn>
-                                        <p:tgtEl>
-                                          <p:spTgt spid="6"/>
-                                        </p:tgtEl>
-                                        <p:attrNameLst>
-                                          <p:attrName>style.visibility</p:attrName>
-                                        </p:attrNameLst>
-                                      </p:cBhvr>
-                                      <p:to>
-                                        <p:strVal val="hidden"/>
-                                      </p:to>
-                                    </p:set>
-                                  </p:childTnLst>
-                                </p:cTn>
-                              </p:par>
                             </p:childTnLst>
                           </p:cTn>
                         </p:par>
@@ -12227,32 +12167,36 @@
                     </p:cTn>
                   </p:par>
                   <p:par>
-                    <p:cTn id="37" fill="hold">
+                    <p:cTn id="31" fill="hold">
                       <p:stCondLst>
                         <p:cond delay="indefinite"/>
                       </p:stCondLst>
                       <p:childTnLst>
                         <p:par>
-                          <p:cTn id="38" fill="hold">
+                          <p:cTn id="32" fill="hold">
                             <p:stCondLst>
                               <p:cond delay="0"/>
                             </p:stCondLst>
                             <p:childTnLst>
                               <p:par>
-                                <p:cTn id="39" presetID="10" presetClass="entr" presetSubtype="0" fill="hold" nodeType="clickEffect">
+                                <p:cTn id="33" presetID="10" presetClass="entr" presetSubtype="0" fill="hold" grpId="0" nodeType="clickEffect">
                                   <p:stCondLst>
                                     <p:cond delay="0"/>
                                   </p:stCondLst>
                                   <p:childTnLst>
                                     <p:set>
                                       <p:cBhvr>
-                                        <p:cTn id="40" dur="1" fill="hold">
+                                        <p:cTn id="34" dur="1" fill="hold">
                                           <p:stCondLst>
                                             <p:cond delay="0"/>
                                           </p:stCondLst>
                                         </p:cTn>
                                         <p:tgtEl>
-                                          <p:spTgt spid="18"/>
+                                          <p:spTgt spid="3">
+                                            <p:txEl>
+                                              <p:pRg st="4" end="4"/>
+                                            </p:txEl>
+                                          </p:spTgt>
                                         </p:tgtEl>
                                         <p:attrNameLst>
                                           <p:attrName>style.visibility</p:attrName>
@@ -12264,12 +12208,86 @@
                                     </p:set>
                                     <p:animEffect transition="in" filter="fade">
                                       <p:cBhvr>
-                                        <p:cTn id="41" dur="500"/>
-                                        <p:tgtEl>
-                                          <p:spTgt spid="18"/>
+                                        <p:cTn id="35" dur="500"/>
+                                        <p:tgtEl>
+                                          <p:spTgt spid="3">
+                                            <p:txEl>
+                                              <p:pRg st="4" end="4"/>
+                                            </p:txEl>
+                                          </p:spTgt>
                                         </p:tgtEl>
                                       </p:cBhvr>
                                     </p:animEffect>
+                                  </p:childTnLst>
+                                </p:cTn>
+                              </p:par>
+                              <p:par>
+                                <p:cTn id="36" presetID="10" presetClass="entr" presetSubtype="0" fill="hold" nodeType="withEffect">
+                                  <p:stCondLst>
+                                    <p:cond delay="0"/>
+                                  </p:stCondLst>
+                                  <p:childTnLst>
+                                    <p:set>
+                                      <p:cBhvr>
+                                        <p:cTn id="37" dur="1" fill="hold">
+                                          <p:stCondLst>
+                                            <p:cond delay="0"/>
+                                          </p:stCondLst>
+                                        </p:cTn>
+                                        <p:tgtEl>
+                                          <p:spTgt spid="15"/>
+                                        </p:tgtEl>
+                                        <p:attrNameLst>
+                                          <p:attrName>style.visibility</p:attrName>
+                                        </p:attrNameLst>
+                                      </p:cBhvr>
+                                      <p:to>
+                                        <p:strVal val="visible"/>
+                                      </p:to>
+                                    </p:set>
+                                    <p:animEffect transition="in" filter="fade">
+                                      <p:cBhvr>
+                                        <p:cTn id="38" dur="500"/>
+                                        <p:tgtEl>
+                                          <p:spTgt spid="15"/>
+                                        </p:tgtEl>
+                                      </p:cBhvr>
+                                    </p:animEffect>
+                                  </p:childTnLst>
+                                </p:cTn>
+                              </p:par>
+                              <p:par>
+                                <p:cTn id="39" presetID="10" presetClass="exit" presetSubtype="0" fill="hold" nodeType="withEffect">
+                                  <p:stCondLst>
+                                    <p:cond delay="0"/>
+                                  </p:stCondLst>
+                                  <p:childTnLst>
+                                    <p:animEffect transition="out" filter="fade">
+                                      <p:cBhvr>
+                                        <p:cTn id="40" dur="500"/>
+                                        <p:tgtEl>
+                                          <p:spTgt spid="6"/>
+                                        </p:tgtEl>
+                                      </p:cBhvr>
+                                    </p:animEffect>
+                                    <p:set>
+                                      <p:cBhvr>
+                                        <p:cTn id="41" dur="1" fill="hold">
+                                          <p:stCondLst>
+                                            <p:cond delay="499"/>
+                                          </p:stCondLst>
+                                        </p:cTn>
+                                        <p:tgtEl>
+                                          <p:spTgt spid="6"/>
+                                        </p:tgtEl>
+                                        <p:attrNameLst>
+                                          <p:attrName>style.visibility</p:attrName>
+                                        </p:attrNameLst>
+                                      </p:cBhvr>
+                                      <p:to>
+                                        <p:strVal val="hidden"/>
+                                      </p:to>
+                                    </p:set>
                                   </p:childTnLst>
                                 </p:cTn>
                               </p:par>
@@ -12305,7 +12323,7 @@
                                           </p:stCondLst>
                                         </p:cTn>
                                         <p:tgtEl>
-                                          <p:spTgt spid="21"/>
+                                          <p:spTgt spid="18"/>
                                         </p:tgtEl>
                                         <p:attrNameLst>
                                           <p:attrName>style.visibility</p:attrName>
@@ -12319,7 +12337,7 @@
                                       <p:cBhvr>
                                         <p:cTn id="46" dur="500"/>
                                         <p:tgtEl>
-                                          <p:spTgt spid="21"/>
+                                          <p:spTgt spid="18"/>
                                         </p:tgtEl>
                                       </p:cBhvr>
                                     </p:animEffect>
@@ -12358,7 +12376,7 @@
                                           </p:stCondLst>
                                         </p:cTn>
                                         <p:tgtEl>
-                                          <p:spTgt spid="26"/>
+                                          <p:spTgt spid="21"/>
                                         </p:tgtEl>
                                         <p:attrNameLst>
                                           <p:attrName>style.visibility</p:attrName>
@@ -12372,7 +12390,7 @@
                                       <p:cBhvr>
                                         <p:cTn id="51" dur="500"/>
                                         <p:tgtEl>
-                                          <p:spTgt spid="26"/>
+                                          <p:spTgt spid="21"/>
                                         </p:tgtEl>
                                       </p:cBhvr>
                                     </p:animEffect>
@@ -12411,7 +12429,7 @@
                                           </p:stCondLst>
                                         </p:cTn>
                                         <p:tgtEl>
-                                          <p:spTgt spid="30"/>
+                                          <p:spTgt spid="26"/>
                                         </p:tgtEl>
                                         <p:attrNameLst>
                                           <p:attrName>style.visibility</p:attrName>
@@ -12425,7 +12443,7 @@
                                       <p:cBhvr>
                                         <p:cTn id="56" dur="500"/>
                                         <p:tgtEl>
-                                          <p:spTgt spid="30"/>
+                                          <p:spTgt spid="26"/>
                                         </p:tgtEl>
                                       </p:cBhvr>
                                     </p:animEffect>
@@ -12464,7 +12482,7 @@
                                           </p:stCondLst>
                                         </p:cTn>
                                         <p:tgtEl>
-                                          <p:spTgt spid="33"/>
+                                          <p:spTgt spid="30"/>
                                         </p:tgtEl>
                                         <p:attrNameLst>
                                           <p:attrName>style.visibility</p:attrName>
@@ -12478,7 +12496,7 @@
                                       <p:cBhvr>
                                         <p:cTn id="61" dur="500"/>
                                         <p:tgtEl>
-                                          <p:spTgt spid="33"/>
+                                          <p:spTgt spid="30"/>
                                         </p:tgtEl>
                                       </p:cBhvr>
                                     </p:animEffect>
@@ -12504,7 +12522,7 @@
                             </p:stCondLst>
                             <p:childTnLst>
                               <p:par>
-                                <p:cTn id="64" presetID="10" presetClass="entr" presetSubtype="0" fill="hold" grpId="0" nodeType="clickEffect">
+                                <p:cTn id="64" presetID="10" presetClass="entr" presetSubtype="0" fill="hold" nodeType="clickEffect">
                                   <p:stCondLst>
                                     <p:cond delay="0"/>
                                   </p:stCondLst>
@@ -12517,11 +12535,7 @@
                                           </p:stCondLst>
                                         </p:cTn>
                                         <p:tgtEl>
-                                          <p:spTgt spid="3">
-                                            <p:txEl>
-                                              <p:pRg st="4" end="4"/>
-                                            </p:txEl>
-                                          </p:spTgt>
+                                          <p:spTgt spid="33"/>
                                         </p:tgtEl>
                                         <p:attrNameLst>
                                           <p:attrName>style.visibility</p:attrName>
@@ -12535,9 +12549,66 @@
                                       <p:cBhvr>
                                         <p:cTn id="66" dur="500"/>
                                         <p:tgtEl>
+                                          <p:spTgt spid="33"/>
+                                        </p:tgtEl>
+                                      </p:cBhvr>
+                                    </p:animEffect>
+                                  </p:childTnLst>
+                                </p:cTn>
+                              </p:par>
+                            </p:childTnLst>
+                          </p:cTn>
+                        </p:par>
+                      </p:childTnLst>
+                    </p:cTn>
+                  </p:par>
+                  <p:par>
+                    <p:cTn id="67" fill="hold">
+                      <p:stCondLst>
+                        <p:cond delay="indefinite"/>
+                      </p:stCondLst>
+                      <p:childTnLst>
+                        <p:par>
+                          <p:cTn id="68" fill="hold">
+                            <p:stCondLst>
+                              <p:cond delay="0"/>
+                            </p:stCondLst>
+                            <p:childTnLst>
+                              <p:par>
+                                <p:cTn id="69" presetID="10" presetClass="entr" presetSubtype="0" fill="hold" grpId="0" nodeType="clickEffect">
+                                  <p:stCondLst>
+                                    <p:cond delay="0"/>
+                                  </p:stCondLst>
+                                  <p:childTnLst>
+                                    <p:set>
+                                      <p:cBhvr>
+                                        <p:cTn id="70" dur="1" fill="hold">
+                                          <p:stCondLst>
+                                            <p:cond delay="0"/>
+                                          </p:stCondLst>
+                                        </p:cTn>
+                                        <p:tgtEl>
                                           <p:spTgt spid="3">
                                             <p:txEl>
-                                              <p:pRg st="4" end="4"/>
+                                              <p:pRg st="5" end="5"/>
+                                            </p:txEl>
+                                          </p:spTgt>
+                                        </p:tgtEl>
+                                        <p:attrNameLst>
+                                          <p:attrName>style.visibility</p:attrName>
+                                        </p:attrNameLst>
+                                      </p:cBhvr>
+                                      <p:to>
+                                        <p:strVal val="visible"/>
+                                      </p:to>
+                                    </p:set>
+                                    <p:animEffect transition="in" filter="fade">
+                                      <p:cBhvr>
+                                        <p:cTn id="71" dur="500"/>
+                                        <p:tgtEl>
+                                          <p:spTgt spid="3">
+                                            <p:txEl>
+                                              <p:pRg st="5" end="5"/>
                                             </p:txEl>
                                           </p:spTgt>
                                         </p:tgtEl>
@@ -12977,8 +13048,8 @@
           </a:p>
         </p:txBody>
       </p:sp>
-      <mc:AlternateContent xmlns:mc="http://schemas.openxmlformats.org/markup-compatibility/2006" xmlns:a14="http://schemas.microsoft.com/office/drawing/2010/main">
-        <mc:Choice Requires="a14">
+      <mc:AlternateContent xmlns:mc="http://schemas.openxmlformats.org/markup-compatibility/2006">
+        <mc:Choice xmlns:a14="http://schemas.microsoft.com/office/drawing/2010/main" Requires="a14">
           <p:sp>
             <p:nvSpPr>
               <p:cNvPr id="3" name="Content Placeholder 2">
@@ -12997,7 +13068,9 @@
             </p:nvSpPr>
             <p:spPr/>
             <p:txBody>
-              <a:bodyPr/>
+              <a:bodyPr>
+                <a:normAutofit lnSpcReduction="10000"/>
+              </a:bodyPr>
               <a:lstStyle/>
               <a:p>
                 <a14:m>
@@ -13196,13 +13269,20 @@
                 <a:pPr lvl="1"/>
                 <a:r>
                   <a:rPr lang="en-GB" dirty="0"/>
-                  <a:t>9 mm longer</a:t>
+                  <a:t>Longer</a:t>
                 </a:r>
               </a:p>
               <a:p>
                 <a:r>
                   <a:rPr lang="en-GB" dirty="0"/>
                   <a:t>By how much?</a:t>
+                </a:r>
+              </a:p>
+              <a:p>
+                <a:pPr lvl="1"/>
+                <a:r>
+                  <a:rPr lang="en-GB" dirty="0"/>
+                  <a:t>9 mm</a:t>
                 </a:r>
               </a:p>
               <a:p>
@@ -13215,13 +13295,13 @@
                 <a:pPr lvl="1"/>
                 <a:r>
                   <a:rPr lang="en-GB" dirty="0"/>
-                  <a:t>Skeena is low hunting, Peace is high</a:t>
+                  <a:t>(Skeena is low hunting, Peace is high)</a:t>
                 </a:r>
               </a:p>
             </p:txBody>
           </p:sp>
         </mc:Choice>
-        <mc:Fallback xmlns="">
+        <mc:Fallback>
           <p:sp>
             <p:nvSpPr>
               <p:cNvPr id="3" name="Content Placeholder 2">
@@ -13242,7 +13322,7 @@
               <a:blipFill>
                 <a:blip r:embed="rId2"/>
                 <a:stretch>
-                  <a:fillRect l="-1770" b="-116"/>
+                  <a:fillRect l="-1770"/>
                 </a:stretch>
               </a:blipFill>
             </p:spPr>
@@ -13804,15 +13884,33 @@
                                   </p:childTnLst>
                                 </p:cTn>
                               </p:par>
+                            </p:childTnLst>
+                          </p:cTn>
+                        </p:par>
+                      </p:childTnLst>
+                    </p:cTn>
+                  </p:par>
+                  <p:par>
+                    <p:cTn id="43" fill="hold">
+                      <p:stCondLst>
+                        <p:cond delay="indefinite"/>
+                      </p:stCondLst>
+                      <p:childTnLst>
+                        <p:par>
+                          <p:cTn id="44" fill="hold">
+                            <p:stCondLst>
+                              <p:cond delay="0"/>
+                            </p:stCondLst>
+                            <p:childTnLst>
                               <p:par>
-                                <p:cTn id="43" presetID="10" presetClass="entr" presetSubtype="0" fill="hold" grpId="0" nodeType="withEffect">
+                                <p:cTn id="45" presetID="10" presetClass="entr" presetSubtype="0" fill="hold" grpId="0" nodeType="clickEffect">
                                   <p:stCondLst>
                                     <p:cond delay="0"/>
                                   </p:stCondLst>
                                   <p:childTnLst>
                                     <p:set>
                                       <p:cBhvr>
-                                        <p:cTn id="44" dur="1" fill="hold">
+                                        <p:cTn id="46" dur="1" fill="hold">
                                           <p:stCondLst>
                                             <p:cond delay="0"/>
                                           </p:stCondLst>
@@ -13834,11 +13932,54 @@
                                     </p:set>
                                     <p:animEffect transition="in" filter="fade">
                                       <p:cBhvr>
-                                        <p:cTn id="45" dur="500"/>
+                                        <p:cTn id="47" dur="500"/>
                                         <p:tgtEl>
                                           <p:spTgt spid="3">
                                             <p:txEl>
                                               <p:pRg st="8" end="8"/>
+                                            </p:txEl>
+                                          </p:spTgt>
+                                        </p:tgtEl>
+                                      </p:cBhvr>
+                                    </p:animEffect>
+                                  </p:childTnLst>
+                                </p:cTn>
+                              </p:par>
+                              <p:par>
+                                <p:cTn id="48" presetID="10" presetClass="entr" presetSubtype="0" fill="hold" grpId="0" nodeType="withEffect">
+                                  <p:stCondLst>
+                                    <p:cond delay="0"/>
+                                  </p:stCondLst>
+                                  <p:childTnLst>
+                                    <p:set>
+                                      <p:cBhvr>
+                                        <p:cTn id="49" dur="1" fill="hold">
+                                          <p:stCondLst>
+                                            <p:cond delay="0"/>
+                                          </p:stCondLst>
+                                        </p:cTn>
+                                        <p:tgtEl>
+                                          <p:spTgt spid="3">
+                                            <p:txEl>
+                                              <p:pRg st="9" end="9"/>
+                                            </p:txEl>
+                                          </p:spTgt>
+                                        </p:tgtEl>
+                                        <p:attrNameLst>
+                                          <p:attrName>style.visibility</p:attrName>
+                                        </p:attrNameLst>
+                                      </p:cBhvr>
+                                      <p:to>
+                                        <p:strVal val="visible"/>
+                                      </p:to>
+                                    </p:set>
+                                    <p:animEffect transition="in" filter="fade">
+                                      <p:cBhvr>
+                                        <p:cTn id="50" dur="500"/>
+                                        <p:tgtEl>
+                                          <p:spTgt spid="3">
+                                            <p:txEl>
+                                              <p:pRg st="9" end="9"/>
                                             </p:txEl>
                                           </p:spTgt>
                                         </p:tgtEl>
@@ -14613,7 +14754,7 @@
           <p:cNvPr id="2" name="Title 1">
             <a:extLst>
               <a:ext uri="{FF2B5EF4-FFF2-40B4-BE49-F238E27FC236}">
-                <a16:creationId xmlns:a16="http://schemas.microsoft.com/office/drawing/2014/main" id="{81A257BF-315C-4A32-0704-0C6DE3E11173}"/>
+                <a16:creationId xmlns:a16="http://schemas.microsoft.com/office/drawing/2014/main" id="{84B4F2B8-5D85-D18D-9CA3-24968E47D26D}"/>
               </a:ext>
             </a:extLst>
           </p:cNvPr>
@@ -14636,850 +14777,16 @@
           </a:p>
         </p:txBody>
       </p:sp>
-      <p:sp>
-        <p:nvSpPr>
-          <p:cNvPr id="3" name="Content Placeholder 2">
-            <a:extLst>
-              <a:ext uri="{FF2B5EF4-FFF2-40B4-BE49-F238E27FC236}">
-                <a16:creationId xmlns:a16="http://schemas.microsoft.com/office/drawing/2014/main" id="{E65184A3-1733-1DDA-EBD7-874A7C6AE257}"/>
-              </a:ext>
-            </a:extLst>
-          </p:cNvPr>
-          <p:cNvSpPr>
-            <a:spLocks noGrp="1"/>
-          </p:cNvSpPr>
-          <p:nvPr>
-            <p:ph idx="1"/>
-          </p:nvPr>
-        </p:nvSpPr>
-        <p:spPr/>
-        <p:txBody>
-          <a:bodyPr>
-            <a:normAutofit/>
-          </a:bodyPr>
-          <a:lstStyle/>
-          <a:p>
-            <a:r>
-              <a:rPr lang="en-GB" dirty="0"/>
-              <a:t>Are you sure there’s a difference?</a:t>
-            </a:r>
-          </a:p>
-          <a:p>
-            <a:r>
-              <a:rPr lang="en-GB" dirty="0"/>
-              <a:t>What if horn length is super variable?</a:t>
-            </a:r>
-          </a:p>
-          <a:p>
-            <a:r>
-              <a:rPr lang="en-GB" dirty="0"/>
-              <a:t>For example, assume you have a medical condition:</a:t>
-            </a:r>
-          </a:p>
-          <a:p>
-            <a:pPr lvl="1"/>
-            <a:r>
-              <a:rPr lang="en-GB" dirty="0"/>
-              <a:t>I offer you two medical drugs</a:t>
-            </a:r>
-          </a:p>
-          <a:p>
-            <a:pPr lvl="1"/>
-            <a:r>
-              <a:rPr lang="en-GB" dirty="0"/>
-              <a:t>Both have side effect of death</a:t>
-            </a:r>
-          </a:p>
-          <a:p>
-            <a:pPr lvl="1"/>
-            <a:r>
-              <a:rPr lang="en-GB" dirty="0"/>
-              <a:t>Which drug do you take?</a:t>
-            </a:r>
-          </a:p>
-          <a:p>
-            <a:pPr lvl="1"/>
-            <a:r>
-              <a:rPr lang="en-GB" dirty="0"/>
-              <a:t>Given uncertainty, which drug do you take?</a:t>
-            </a:r>
-          </a:p>
-          <a:p>
-            <a:r>
-              <a:rPr lang="en-GB" dirty="0"/>
-              <a:t>How do we calculate uncertainty?</a:t>
-            </a:r>
-          </a:p>
-        </p:txBody>
-      </p:sp>
-      <p:pic>
-        <p:nvPicPr>
-          <p:cNvPr id="8" name="Picture Placeholder 7" descr="A screenshot of a graph&#10;&#10;Description automatically generated">
-            <a:extLst>
-              <a:ext uri="{FF2B5EF4-FFF2-40B4-BE49-F238E27FC236}">
-                <a16:creationId xmlns:a16="http://schemas.microsoft.com/office/drawing/2014/main" id="{4028A641-E759-5F22-0849-E6C3790972B6}"/>
-              </a:ext>
-            </a:extLst>
-          </p:cNvPr>
-          <p:cNvPicPr>
-            <a:picLocks noGrp="1" noChangeAspect="1"/>
-          </p:cNvPicPr>
-          <p:nvPr>
-            <p:ph type="pic" sz="quarter" idx="10"/>
-          </p:nvPr>
-        </p:nvPicPr>
-        <p:blipFill>
-          <a:blip r:embed="rId2">
-            <a:extLst>
-              <a:ext uri="{28A0092B-C50C-407E-A947-70E740481C1C}">
-                <a14:useLocalDpi xmlns:a14="http://schemas.microsoft.com/office/drawing/2010/main" val="0"/>
-              </a:ext>
-            </a:extLst>
-          </a:blip>
-          <a:srcRect t="691" b="691"/>
-          <a:stretch>
-            <a:fillRect/>
-          </a:stretch>
-        </p:blipFill>
-        <p:spPr/>
-      </p:pic>
-      <p:pic>
-        <p:nvPicPr>
-          <p:cNvPr id="7" name="Picture 6" descr="A screenshot of a graph&#10;&#10;Description automatically generated">
-            <a:extLst>
-              <a:ext uri="{FF2B5EF4-FFF2-40B4-BE49-F238E27FC236}">
-                <a16:creationId xmlns:a16="http://schemas.microsoft.com/office/drawing/2014/main" id="{6944D16A-37C0-8E58-65CE-67E4BD9F7E41}"/>
-              </a:ext>
-            </a:extLst>
-          </p:cNvPr>
-          <p:cNvPicPr>
-            <a:picLocks noChangeAspect="1"/>
-          </p:cNvPicPr>
-          <p:nvPr/>
-        </p:nvPicPr>
-        <p:blipFill>
-          <a:blip r:embed="rId3">
-            <a:extLst>
-              <a:ext uri="{28A0092B-C50C-407E-A947-70E740481C1C}">
-                <a14:useLocalDpi xmlns:a14="http://schemas.microsoft.com/office/drawing/2010/main" val="0"/>
-              </a:ext>
-            </a:extLst>
-          </a:blip>
-          <a:stretch>
-            <a:fillRect/>
-          </a:stretch>
-        </p:blipFill>
-        <p:spPr>
-          <a:xfrm>
-            <a:off x="6359525" y="0"/>
-            <a:ext cx="5751871" cy="6858000"/>
-          </a:xfrm>
-          <a:prstGeom prst="rect">
-            <a:avLst/>
-          </a:prstGeom>
-        </p:spPr>
-      </p:pic>
-      <p:pic>
-        <p:nvPicPr>
-          <p:cNvPr id="10" name="Picture 9" descr="A screen shot of a graph&#10;&#10;Description automatically generated">
-            <a:extLst>
-              <a:ext uri="{FF2B5EF4-FFF2-40B4-BE49-F238E27FC236}">
-                <a16:creationId xmlns:a16="http://schemas.microsoft.com/office/drawing/2014/main" id="{42012E3D-5286-4200-1413-99AB9C444275}"/>
-              </a:ext>
-            </a:extLst>
-          </p:cNvPr>
-          <p:cNvPicPr>
-            <a:picLocks noChangeAspect="1"/>
-          </p:cNvPicPr>
-          <p:nvPr/>
-        </p:nvPicPr>
-        <p:blipFill>
-          <a:blip r:embed="rId4">
-            <a:extLst>
-              <a:ext uri="{28A0092B-C50C-407E-A947-70E740481C1C}">
-                <a14:useLocalDpi xmlns:a14="http://schemas.microsoft.com/office/drawing/2010/main" val="0"/>
-              </a:ext>
-            </a:extLst>
-          </a:blip>
-          <a:stretch>
-            <a:fillRect/>
-          </a:stretch>
-        </p:blipFill>
-        <p:spPr>
-          <a:xfrm>
-            <a:off x="6359524" y="0"/>
-            <a:ext cx="5751871" cy="6858000"/>
-          </a:xfrm>
-          <a:prstGeom prst="rect">
-            <a:avLst/>
-          </a:prstGeom>
-        </p:spPr>
-      </p:pic>
     </p:spTree>
     <p:extLst>
       <p:ext uri="{BB962C8B-B14F-4D97-AF65-F5344CB8AC3E}">
-        <p14:creationId xmlns:p14="http://schemas.microsoft.com/office/powerpoint/2010/main" val="2591613455"/>
+        <p14:creationId xmlns:p14="http://schemas.microsoft.com/office/powerpoint/2010/main" val="1175870486"/>
       </p:ext>
     </p:extLst>
   </p:cSld>
   <p:clrMapOvr>
     <a:masterClrMapping/>
   </p:clrMapOvr>
-  <mc:AlternateContent xmlns:mc="http://schemas.openxmlformats.org/markup-compatibility/2006" xmlns:p14="http://schemas.microsoft.com/office/powerpoint/2010/main">
-    <mc:Choice Requires="p14">
-      <p:transition spd="med" p14:dur="700">
-        <p:fade/>
-      </p:transition>
-    </mc:Choice>
-    <mc:Fallback xmlns="">
-      <p:transition spd="med">
-        <p:fade/>
-      </p:transition>
-    </mc:Fallback>
-  </mc:AlternateContent>
-  <p:timing>
-    <p:tnLst>
-      <p:par>
-        <p:cTn id="1" dur="indefinite" restart="never" nodeType="tmRoot">
-          <p:childTnLst>
-            <p:seq concurrent="1" nextAc="seek">
-              <p:cTn id="2" dur="indefinite" nodeType="mainSeq">
-                <p:childTnLst>
-                  <p:par>
-                    <p:cTn id="3" fill="hold">
-                      <p:stCondLst>
-                        <p:cond delay="indefinite"/>
-                      </p:stCondLst>
-                      <p:childTnLst>
-                        <p:par>
-                          <p:cTn id="4" fill="hold">
-                            <p:stCondLst>
-                              <p:cond delay="0"/>
-                            </p:stCondLst>
-                            <p:childTnLst>
-                              <p:par>
-                                <p:cTn id="5" presetID="10" presetClass="entr" presetSubtype="0" fill="hold" grpId="0" nodeType="clickEffect">
-                                  <p:stCondLst>
-                                    <p:cond delay="0"/>
-                                  </p:stCondLst>
-                                  <p:childTnLst>
-                                    <p:set>
-                                      <p:cBhvr>
-                                        <p:cTn id="6" dur="1" fill="hold">
-                                          <p:stCondLst>
-                                            <p:cond delay="0"/>
-                                          </p:stCondLst>
-                                        </p:cTn>
-                                        <p:tgtEl>
-                                          <p:spTgt spid="3">
-                                            <p:txEl>
-                                              <p:pRg st="0" end="0"/>
-                                            </p:txEl>
-                                          </p:spTgt>
-                                        </p:tgtEl>
-                                        <p:attrNameLst>
-                                          <p:attrName>style.visibility</p:attrName>
-                                        </p:attrNameLst>
-                                      </p:cBhvr>
-                                      <p:to>
-                                        <p:strVal val="visible"/>
-                                      </p:to>
-                                    </p:set>
-                                    <p:animEffect transition="in" filter="fade">
-                                      <p:cBhvr>
-                                        <p:cTn id="7" dur="500"/>
-                                        <p:tgtEl>
-                                          <p:spTgt spid="3">
-                                            <p:txEl>
-                                              <p:pRg st="0" end="0"/>
-                                            </p:txEl>
-                                          </p:spTgt>
-                                        </p:tgtEl>
-                                      </p:cBhvr>
-                                    </p:animEffect>
-                                  </p:childTnLst>
-                                </p:cTn>
-                              </p:par>
-                            </p:childTnLst>
-                          </p:cTn>
-                        </p:par>
-                      </p:childTnLst>
-                    </p:cTn>
-                  </p:par>
-                  <p:par>
-                    <p:cTn id="8" fill="hold">
-                      <p:stCondLst>
-                        <p:cond delay="indefinite"/>
-                      </p:stCondLst>
-                      <p:childTnLst>
-                        <p:par>
-                          <p:cTn id="9" fill="hold">
-                            <p:stCondLst>
-                              <p:cond delay="0"/>
-                            </p:stCondLst>
-                            <p:childTnLst>
-                              <p:par>
-                                <p:cTn id="10" presetID="10" presetClass="entr" presetSubtype="0" fill="hold" grpId="0" nodeType="clickEffect">
-                                  <p:stCondLst>
-                                    <p:cond delay="0"/>
-                                  </p:stCondLst>
-                                  <p:childTnLst>
-                                    <p:set>
-                                      <p:cBhvr>
-                                        <p:cTn id="11" dur="1" fill="hold">
-                                          <p:stCondLst>
-                                            <p:cond delay="0"/>
-                                          </p:stCondLst>
-                                        </p:cTn>
-                                        <p:tgtEl>
-                                          <p:spTgt spid="3">
-                                            <p:txEl>
-                                              <p:pRg st="1" end="1"/>
-                                            </p:txEl>
-                                          </p:spTgt>
-                                        </p:tgtEl>
-                                        <p:attrNameLst>
-                                          <p:attrName>style.visibility</p:attrName>
-                                        </p:attrNameLst>
-                                      </p:cBhvr>
-                                      <p:to>
-                                        <p:strVal val="visible"/>
-                                      </p:to>
-                                    </p:set>
-                                    <p:animEffect transition="in" filter="fade">
-                                      <p:cBhvr>
-                                        <p:cTn id="12" dur="500"/>
-                                        <p:tgtEl>
-                                          <p:spTgt spid="3">
-                                            <p:txEl>
-                                              <p:pRg st="1" end="1"/>
-                                            </p:txEl>
-                                          </p:spTgt>
-                                        </p:tgtEl>
-                                      </p:cBhvr>
-                                    </p:animEffect>
-                                  </p:childTnLst>
-                                </p:cTn>
-                              </p:par>
-                            </p:childTnLst>
-                          </p:cTn>
-                        </p:par>
-                      </p:childTnLst>
-                    </p:cTn>
-                  </p:par>
-                  <p:par>
-                    <p:cTn id="13" fill="hold">
-                      <p:stCondLst>
-                        <p:cond delay="indefinite"/>
-                      </p:stCondLst>
-                      <p:childTnLst>
-                        <p:par>
-                          <p:cTn id="14" fill="hold">
-                            <p:stCondLst>
-                              <p:cond delay="0"/>
-                            </p:stCondLst>
-                            <p:childTnLst>
-                              <p:par>
-                                <p:cTn id="15" presetID="10" presetClass="entr" presetSubtype="0" fill="hold" grpId="0" nodeType="clickEffect">
-                                  <p:stCondLst>
-                                    <p:cond delay="0"/>
-                                  </p:stCondLst>
-                                  <p:childTnLst>
-                                    <p:set>
-                                      <p:cBhvr>
-                                        <p:cTn id="16" dur="1" fill="hold">
-                                          <p:stCondLst>
-                                            <p:cond delay="0"/>
-                                          </p:stCondLst>
-                                        </p:cTn>
-                                        <p:tgtEl>
-                                          <p:spTgt spid="3">
-                                            <p:txEl>
-                                              <p:pRg st="2" end="2"/>
-                                            </p:txEl>
-                                          </p:spTgt>
-                                        </p:tgtEl>
-                                        <p:attrNameLst>
-                                          <p:attrName>style.visibility</p:attrName>
-                                        </p:attrNameLst>
-                                      </p:cBhvr>
-                                      <p:to>
-                                        <p:strVal val="visible"/>
-                                      </p:to>
-                                    </p:set>
-                                    <p:animEffect transition="in" filter="fade">
-                                      <p:cBhvr>
-                                        <p:cTn id="17" dur="500"/>
-                                        <p:tgtEl>
-                                          <p:spTgt spid="3">
-                                            <p:txEl>
-                                              <p:pRg st="2" end="2"/>
-                                            </p:txEl>
-                                          </p:spTgt>
-                                        </p:tgtEl>
-                                      </p:cBhvr>
-                                    </p:animEffect>
-                                  </p:childTnLst>
-                                </p:cTn>
-                              </p:par>
-                              <p:par>
-                                <p:cTn id="18" presetID="10" presetClass="entr" presetSubtype="0" fill="hold" grpId="0" nodeType="withEffect">
-                                  <p:stCondLst>
-                                    <p:cond delay="0"/>
-                                  </p:stCondLst>
-                                  <p:childTnLst>
-                                    <p:set>
-                                      <p:cBhvr>
-                                        <p:cTn id="19" dur="1" fill="hold">
-                                          <p:stCondLst>
-                                            <p:cond delay="0"/>
-                                          </p:stCondLst>
-                                        </p:cTn>
-                                        <p:tgtEl>
-                                          <p:spTgt spid="3">
-                                            <p:txEl>
-                                              <p:pRg st="3" end="3"/>
-                                            </p:txEl>
-                                          </p:spTgt>
-                                        </p:tgtEl>
-                                        <p:attrNameLst>
-                                          <p:attrName>style.visibility</p:attrName>
-                                        </p:attrNameLst>
-                                      </p:cBhvr>
-                                      <p:to>
-                                        <p:strVal val="visible"/>
-                                      </p:to>
-                                    </p:set>
-                                    <p:animEffect transition="in" filter="fade">
-                                      <p:cBhvr>
-                                        <p:cTn id="20" dur="500"/>
-                                        <p:tgtEl>
-                                          <p:spTgt spid="3">
-                                            <p:txEl>
-                                              <p:pRg st="3" end="3"/>
-                                            </p:txEl>
-                                          </p:spTgt>
-                                        </p:tgtEl>
-                                      </p:cBhvr>
-                                    </p:animEffect>
-                                  </p:childTnLst>
-                                </p:cTn>
-                              </p:par>
-                              <p:par>
-                                <p:cTn id="21" presetID="10" presetClass="entr" presetSubtype="0" fill="hold" nodeType="withEffect">
-                                  <p:stCondLst>
-                                    <p:cond delay="0"/>
-                                  </p:stCondLst>
-                                  <p:childTnLst>
-                                    <p:set>
-                                      <p:cBhvr>
-                                        <p:cTn id="22" dur="1" fill="hold">
-                                          <p:stCondLst>
-                                            <p:cond delay="0"/>
-                                          </p:stCondLst>
-                                        </p:cTn>
-                                        <p:tgtEl>
-                                          <p:spTgt spid="7"/>
-                                        </p:tgtEl>
-                                        <p:attrNameLst>
-                                          <p:attrName>style.visibility</p:attrName>
-                                        </p:attrNameLst>
-                                      </p:cBhvr>
-                                      <p:to>
-                                        <p:strVal val="visible"/>
-                                      </p:to>
-                                    </p:set>
-                                    <p:animEffect transition="in" filter="fade">
-                                      <p:cBhvr>
-                                        <p:cTn id="23" dur="500"/>
-                                        <p:tgtEl>
-                                          <p:spTgt spid="7"/>
-                                        </p:tgtEl>
-                                      </p:cBhvr>
-                                    </p:animEffect>
-                                  </p:childTnLst>
-                                </p:cTn>
-                              </p:par>
-                            </p:childTnLst>
-                          </p:cTn>
-                        </p:par>
-                      </p:childTnLst>
-                    </p:cTn>
-                  </p:par>
-                  <p:par>
-                    <p:cTn id="24" fill="hold">
-                      <p:stCondLst>
-                        <p:cond delay="indefinite"/>
-                      </p:stCondLst>
-                      <p:childTnLst>
-                        <p:par>
-                          <p:cTn id="25" fill="hold">
-                            <p:stCondLst>
-                              <p:cond delay="0"/>
-                            </p:stCondLst>
-                            <p:childTnLst>
-                              <p:par>
-                                <p:cTn id="26" presetID="10" presetClass="entr" presetSubtype="0" fill="hold" grpId="0" nodeType="clickEffect">
-                                  <p:stCondLst>
-                                    <p:cond delay="0"/>
-                                  </p:stCondLst>
-                                  <p:childTnLst>
-                                    <p:set>
-                                      <p:cBhvr>
-                                        <p:cTn id="27" dur="1" fill="hold">
-                                          <p:stCondLst>
-                                            <p:cond delay="0"/>
-                                          </p:stCondLst>
-                                        </p:cTn>
-                                        <p:tgtEl>
-                                          <p:spTgt spid="3">
-                                            <p:txEl>
-                                              <p:pRg st="4" end="4"/>
-                                            </p:txEl>
-                                          </p:spTgt>
-                                        </p:tgtEl>
-                                        <p:attrNameLst>
-                                          <p:attrName>style.visibility</p:attrName>
-                                        </p:attrNameLst>
-                                      </p:cBhvr>
-                                      <p:to>
-                                        <p:strVal val="visible"/>
-                                      </p:to>
-                                    </p:set>
-                                    <p:animEffect transition="in" filter="fade">
-                                      <p:cBhvr>
-                                        <p:cTn id="28" dur="500"/>
-                                        <p:tgtEl>
-                                          <p:spTgt spid="3">
-                                            <p:txEl>
-                                              <p:pRg st="4" end="4"/>
-                                            </p:txEl>
-                                          </p:spTgt>
-                                        </p:tgtEl>
-                                      </p:cBhvr>
-                                    </p:animEffect>
-                                  </p:childTnLst>
-                                </p:cTn>
-                              </p:par>
-                            </p:childTnLst>
-                          </p:cTn>
-                        </p:par>
-                      </p:childTnLst>
-                    </p:cTn>
-                  </p:par>
-                  <p:par>
-                    <p:cTn id="29" fill="hold">
-                      <p:stCondLst>
-                        <p:cond delay="indefinite"/>
-                      </p:stCondLst>
-                      <p:childTnLst>
-                        <p:par>
-                          <p:cTn id="30" fill="hold">
-                            <p:stCondLst>
-                              <p:cond delay="0"/>
-                            </p:stCondLst>
-                            <p:childTnLst>
-                              <p:par>
-                                <p:cTn id="31" presetID="10" presetClass="entr" presetSubtype="0" fill="hold" grpId="0" nodeType="clickEffect">
-                                  <p:stCondLst>
-                                    <p:cond delay="0"/>
-                                  </p:stCondLst>
-                                  <p:childTnLst>
-                                    <p:set>
-                                      <p:cBhvr>
-                                        <p:cTn id="32" dur="1" fill="hold">
-                                          <p:stCondLst>
-                                            <p:cond delay="0"/>
-                                          </p:stCondLst>
-                                        </p:cTn>
-                                        <p:tgtEl>
-                                          <p:spTgt spid="3">
-                                            <p:txEl>
-                                              <p:pRg st="5" end="5"/>
-                                            </p:txEl>
-                                          </p:spTgt>
-                                        </p:tgtEl>
-                                        <p:attrNameLst>
-                                          <p:attrName>style.visibility</p:attrName>
-                                        </p:attrNameLst>
-                                      </p:cBhvr>
-                                      <p:to>
-                                        <p:strVal val="visible"/>
-                                      </p:to>
-                                    </p:set>
-                                    <p:animEffect transition="in" filter="fade">
-                                      <p:cBhvr>
-                                        <p:cTn id="33" dur="500"/>
-                                        <p:tgtEl>
-                                          <p:spTgt spid="3">
-                                            <p:txEl>
-                                              <p:pRg st="5" end="5"/>
-                                            </p:txEl>
-                                          </p:spTgt>
-                                        </p:tgtEl>
-                                      </p:cBhvr>
-                                    </p:animEffect>
-                                  </p:childTnLst>
-                                </p:cTn>
-                              </p:par>
-                            </p:childTnLst>
-                          </p:cTn>
-                        </p:par>
-                      </p:childTnLst>
-                    </p:cTn>
-                  </p:par>
-                  <p:par>
-                    <p:cTn id="34" fill="hold">
-                      <p:stCondLst>
-                        <p:cond delay="indefinite"/>
-                      </p:stCondLst>
-                      <p:childTnLst>
-                        <p:par>
-                          <p:cTn id="35" fill="hold">
-                            <p:stCondLst>
-                              <p:cond delay="0"/>
-                            </p:stCondLst>
-                            <p:childTnLst>
-                              <p:par>
-                                <p:cTn id="36" presetID="10" presetClass="entr" presetSubtype="0" fill="hold" grpId="0" nodeType="clickEffect">
-                                  <p:stCondLst>
-                                    <p:cond delay="0"/>
-                                  </p:stCondLst>
-                                  <p:childTnLst>
-                                    <p:set>
-                                      <p:cBhvr>
-                                        <p:cTn id="37" dur="1" fill="hold">
-                                          <p:stCondLst>
-                                            <p:cond delay="0"/>
-                                          </p:stCondLst>
-                                        </p:cTn>
-                                        <p:tgtEl>
-                                          <p:spTgt spid="3">
-                                            <p:txEl>
-                                              <p:pRg st="6" end="6"/>
-                                            </p:txEl>
-                                          </p:spTgt>
-                                        </p:tgtEl>
-                                        <p:attrNameLst>
-                                          <p:attrName>style.visibility</p:attrName>
-                                        </p:attrNameLst>
-                                      </p:cBhvr>
-                                      <p:to>
-                                        <p:strVal val="visible"/>
-                                      </p:to>
-                                    </p:set>
-                                    <p:animEffect transition="in" filter="fade">
-                                      <p:cBhvr>
-                                        <p:cTn id="38" dur="500"/>
-                                        <p:tgtEl>
-                                          <p:spTgt spid="3">
-                                            <p:txEl>
-                                              <p:pRg st="6" end="6"/>
-                                            </p:txEl>
-                                          </p:spTgt>
-                                        </p:tgtEl>
-                                      </p:cBhvr>
-                                    </p:animEffect>
-                                  </p:childTnLst>
-                                </p:cTn>
-                              </p:par>
-                              <p:par>
-                                <p:cTn id="39" presetID="10" presetClass="entr" presetSubtype="0" fill="hold" nodeType="withEffect">
-                                  <p:stCondLst>
-                                    <p:cond delay="0"/>
-                                  </p:stCondLst>
-                                  <p:childTnLst>
-                                    <p:set>
-                                      <p:cBhvr>
-                                        <p:cTn id="40" dur="1" fill="hold">
-                                          <p:stCondLst>
-                                            <p:cond delay="0"/>
-                                          </p:stCondLst>
-                                        </p:cTn>
-                                        <p:tgtEl>
-                                          <p:spTgt spid="10"/>
-                                        </p:tgtEl>
-                                        <p:attrNameLst>
-                                          <p:attrName>style.visibility</p:attrName>
-                                        </p:attrNameLst>
-                                      </p:cBhvr>
-                                      <p:to>
-                                        <p:strVal val="visible"/>
-                                      </p:to>
-                                    </p:set>
-                                    <p:animEffect transition="in" filter="fade">
-                                      <p:cBhvr>
-                                        <p:cTn id="41" dur="500"/>
-                                        <p:tgtEl>
-                                          <p:spTgt spid="10"/>
-                                        </p:tgtEl>
-                                      </p:cBhvr>
-                                    </p:animEffect>
-                                  </p:childTnLst>
-                                </p:cTn>
-                              </p:par>
-                            </p:childTnLst>
-                          </p:cTn>
-                        </p:par>
-                      </p:childTnLst>
-                    </p:cTn>
-                  </p:par>
-                  <p:par>
-                    <p:cTn id="42" fill="hold">
-                      <p:stCondLst>
-                        <p:cond delay="indefinite"/>
-                      </p:stCondLst>
-                      <p:childTnLst>
-                        <p:par>
-                          <p:cTn id="43" fill="hold">
-                            <p:stCondLst>
-                              <p:cond delay="0"/>
-                            </p:stCondLst>
-                            <p:childTnLst>
-                              <p:par>
-                                <p:cTn id="44" presetID="10" presetClass="entr" presetSubtype="0" fill="hold" grpId="0" nodeType="clickEffect">
-                                  <p:stCondLst>
-                                    <p:cond delay="0"/>
-                                  </p:stCondLst>
-                                  <p:childTnLst>
-                                    <p:set>
-                                      <p:cBhvr>
-                                        <p:cTn id="45" dur="1" fill="hold">
-                                          <p:stCondLst>
-                                            <p:cond delay="0"/>
-                                          </p:stCondLst>
-                                        </p:cTn>
-                                        <p:tgtEl>
-                                          <p:spTgt spid="3">
-                                            <p:txEl>
-                                              <p:pRg st="7" end="7"/>
-                                            </p:txEl>
-                                          </p:spTgt>
-                                        </p:tgtEl>
-                                        <p:attrNameLst>
-                                          <p:attrName>style.visibility</p:attrName>
-                                        </p:attrNameLst>
-                                      </p:cBhvr>
-                                      <p:to>
-                                        <p:strVal val="visible"/>
-                                      </p:to>
-                                    </p:set>
-                                    <p:animEffect transition="in" filter="fade">
-                                      <p:cBhvr>
-                                        <p:cTn id="46" dur="500"/>
-                                        <p:tgtEl>
-                                          <p:spTgt spid="3">
-                                            <p:txEl>
-                                              <p:pRg st="7" end="7"/>
-                                            </p:txEl>
-                                          </p:spTgt>
-                                        </p:tgtEl>
-                                      </p:cBhvr>
-                                    </p:animEffect>
-                                  </p:childTnLst>
-                                </p:cTn>
-                              </p:par>
-                              <p:par>
-                                <p:cTn id="47" presetID="10" presetClass="exit" presetSubtype="0" fill="hold" nodeType="withEffect">
-                                  <p:stCondLst>
-                                    <p:cond delay="0"/>
-                                  </p:stCondLst>
-                                  <p:childTnLst>
-                                    <p:animEffect transition="out" filter="fade">
-                                      <p:cBhvr>
-                                        <p:cTn id="48" dur="500"/>
-                                        <p:tgtEl>
-                                          <p:spTgt spid="7"/>
-                                        </p:tgtEl>
-                                      </p:cBhvr>
-                                    </p:animEffect>
-                                    <p:set>
-                                      <p:cBhvr>
-                                        <p:cTn id="49" dur="1" fill="hold">
-                                          <p:stCondLst>
-                                            <p:cond delay="499"/>
-                                          </p:stCondLst>
-                                        </p:cTn>
-                                        <p:tgtEl>
-                                          <p:spTgt spid="7"/>
-                                        </p:tgtEl>
-                                        <p:attrNameLst>
-                                          <p:attrName>style.visibility</p:attrName>
-                                        </p:attrNameLst>
-                                      </p:cBhvr>
-                                      <p:to>
-                                        <p:strVal val="hidden"/>
-                                      </p:to>
-                                    </p:set>
-                                  </p:childTnLst>
-                                </p:cTn>
-                              </p:par>
-                              <p:par>
-                                <p:cTn id="50" presetID="10" presetClass="exit" presetSubtype="0" fill="hold" nodeType="withEffect">
-                                  <p:stCondLst>
-                                    <p:cond delay="0"/>
-                                  </p:stCondLst>
-                                  <p:childTnLst>
-                                    <p:animEffect transition="out" filter="fade">
-                                      <p:cBhvr>
-                                        <p:cTn id="51" dur="500"/>
-                                        <p:tgtEl>
-                                          <p:spTgt spid="10"/>
-                                        </p:tgtEl>
-                                      </p:cBhvr>
-                                    </p:animEffect>
-                                    <p:set>
-                                      <p:cBhvr>
-                                        <p:cTn id="52" dur="1" fill="hold">
-                                          <p:stCondLst>
-                                            <p:cond delay="499"/>
-                                          </p:stCondLst>
-                                        </p:cTn>
-                                        <p:tgtEl>
-                                          <p:spTgt spid="10"/>
-                                        </p:tgtEl>
-                                        <p:attrNameLst>
-                                          <p:attrName>style.visibility</p:attrName>
-                                        </p:attrNameLst>
-                                      </p:cBhvr>
-                                      <p:to>
-                                        <p:strVal val="hidden"/>
-                                      </p:to>
-                                    </p:set>
-                                  </p:childTnLst>
-                                </p:cTn>
-                              </p:par>
-                            </p:childTnLst>
-                          </p:cTn>
-                        </p:par>
-                      </p:childTnLst>
-                    </p:cTn>
-                  </p:par>
-                </p:childTnLst>
-              </p:cTn>
-              <p:prevCondLst>
-                <p:cond evt="onPrev" delay="0">
-                  <p:tgtEl>
-                    <p:sldTgt/>
-                  </p:tgtEl>
-                </p:cond>
-              </p:prevCondLst>
-              <p:nextCondLst>
-                <p:cond evt="onNext" delay="0">
-                  <p:tgtEl>
-                    <p:sldTgt/>
-                  </p:tgtEl>
-                </p:cond>
-              </p:nextCondLst>
-            </p:seq>
-          </p:childTnLst>
-        </p:cTn>
-      </p:par>
-    </p:tnLst>
-    <p:bldLst>
-      <p:bldP spid="3" grpId="0" uiExpand="1" build="p"/>
-    </p:bldLst>
-  </p:timing>
 </p:sld>
 </file>
 
@@ -15808,6 +15115,898 @@
 </file>
 
 <file path=ppt/slides/slide20.xml><?xml version="1.0" encoding="utf-8"?>
+<p:sld xmlns:a="http://schemas.openxmlformats.org/drawingml/2006/main" xmlns:r="http://schemas.openxmlformats.org/officeDocument/2006/relationships" xmlns:p="http://schemas.openxmlformats.org/presentationml/2006/main">
+  <p:cSld>
+    <p:spTree>
+      <p:nvGrpSpPr>
+        <p:cNvPr id="1" name=""/>
+        <p:cNvGrpSpPr/>
+        <p:nvPr/>
+      </p:nvGrpSpPr>
+      <p:grpSpPr>
+        <a:xfrm>
+          <a:off x="0" y="0"/>
+          <a:ext cx="0" cy="0"/>
+          <a:chOff x="0" y="0"/>
+          <a:chExt cx="0" cy="0"/>
+        </a:xfrm>
+      </p:grpSpPr>
+      <p:sp>
+        <p:nvSpPr>
+          <p:cNvPr id="2" name="Title 1">
+            <a:extLst>
+              <a:ext uri="{FF2B5EF4-FFF2-40B4-BE49-F238E27FC236}">
+                <a16:creationId xmlns:a16="http://schemas.microsoft.com/office/drawing/2014/main" id="{81A257BF-315C-4A32-0704-0C6DE3E11173}"/>
+              </a:ext>
+            </a:extLst>
+          </p:cNvPr>
+          <p:cNvSpPr>
+            <a:spLocks noGrp="1"/>
+          </p:cNvSpPr>
+          <p:nvPr>
+            <p:ph type="title"/>
+          </p:nvPr>
+        </p:nvSpPr>
+        <p:spPr/>
+        <p:txBody>
+          <a:bodyPr/>
+          <a:lstStyle/>
+          <a:p>
+            <a:r>
+              <a:rPr lang="en-GB" dirty="0"/>
+              <a:t>Uncertainty</a:t>
+            </a:r>
+          </a:p>
+        </p:txBody>
+      </p:sp>
+      <p:sp>
+        <p:nvSpPr>
+          <p:cNvPr id="3" name="Content Placeholder 2">
+            <a:extLst>
+              <a:ext uri="{FF2B5EF4-FFF2-40B4-BE49-F238E27FC236}">
+                <a16:creationId xmlns:a16="http://schemas.microsoft.com/office/drawing/2014/main" id="{E65184A3-1733-1DDA-EBD7-874A7C6AE257}"/>
+              </a:ext>
+            </a:extLst>
+          </p:cNvPr>
+          <p:cNvSpPr>
+            <a:spLocks noGrp="1"/>
+          </p:cNvSpPr>
+          <p:nvPr>
+            <p:ph idx="1"/>
+          </p:nvPr>
+        </p:nvSpPr>
+        <p:spPr/>
+        <p:txBody>
+          <a:bodyPr>
+            <a:normAutofit/>
+          </a:bodyPr>
+          <a:lstStyle/>
+          <a:p>
+            <a:r>
+              <a:rPr lang="en-GB" dirty="0"/>
+              <a:t>Are you sure there’s a difference?</a:t>
+            </a:r>
+          </a:p>
+          <a:p>
+            <a:r>
+              <a:rPr lang="en-GB" dirty="0"/>
+              <a:t>What if horn length is super variable?</a:t>
+            </a:r>
+          </a:p>
+          <a:p>
+            <a:r>
+              <a:rPr lang="en-GB" dirty="0"/>
+              <a:t>For example, assume you have a medical condition:</a:t>
+            </a:r>
+          </a:p>
+          <a:p>
+            <a:pPr lvl="1"/>
+            <a:r>
+              <a:rPr lang="en-GB" dirty="0"/>
+              <a:t>I offer you two medical drugs</a:t>
+            </a:r>
+          </a:p>
+          <a:p>
+            <a:pPr lvl="1"/>
+            <a:r>
+              <a:rPr lang="en-GB" dirty="0"/>
+              <a:t>Both have side effect of death</a:t>
+            </a:r>
+          </a:p>
+          <a:p>
+            <a:pPr lvl="1"/>
+            <a:r>
+              <a:rPr lang="en-GB" dirty="0"/>
+              <a:t>Which drug do you take?</a:t>
+            </a:r>
+          </a:p>
+          <a:p>
+            <a:pPr lvl="1"/>
+            <a:r>
+              <a:rPr lang="en-GB" dirty="0"/>
+              <a:t>Given uncertainty, which drug do you take?</a:t>
+            </a:r>
+          </a:p>
+          <a:p>
+            <a:r>
+              <a:rPr lang="en-GB" dirty="0"/>
+              <a:t>How do we calculate uncertainty?</a:t>
+            </a:r>
+          </a:p>
+        </p:txBody>
+      </p:sp>
+      <p:pic>
+        <p:nvPicPr>
+          <p:cNvPr id="8" name="Picture Placeholder 7" descr="A screenshot of a graph&#10;&#10;Description automatically generated">
+            <a:extLst>
+              <a:ext uri="{FF2B5EF4-FFF2-40B4-BE49-F238E27FC236}">
+                <a16:creationId xmlns:a16="http://schemas.microsoft.com/office/drawing/2014/main" id="{4028A641-E759-5F22-0849-E6C3790972B6}"/>
+              </a:ext>
+            </a:extLst>
+          </p:cNvPr>
+          <p:cNvPicPr>
+            <a:picLocks noGrp="1" noChangeAspect="1"/>
+          </p:cNvPicPr>
+          <p:nvPr>
+            <p:ph type="pic" sz="quarter" idx="10"/>
+          </p:nvPr>
+        </p:nvPicPr>
+        <p:blipFill>
+          <a:blip r:embed="rId2">
+            <a:extLst>
+              <a:ext uri="{28A0092B-C50C-407E-A947-70E740481C1C}">
+                <a14:useLocalDpi xmlns:a14="http://schemas.microsoft.com/office/drawing/2010/main" val="0"/>
+              </a:ext>
+            </a:extLst>
+          </a:blip>
+          <a:srcRect t="691" b="691"/>
+          <a:stretch>
+            <a:fillRect/>
+          </a:stretch>
+        </p:blipFill>
+        <p:spPr/>
+      </p:pic>
+      <p:pic>
+        <p:nvPicPr>
+          <p:cNvPr id="7" name="Picture 6" descr="A screenshot of a graph&#10;&#10;Description automatically generated">
+            <a:extLst>
+              <a:ext uri="{FF2B5EF4-FFF2-40B4-BE49-F238E27FC236}">
+                <a16:creationId xmlns:a16="http://schemas.microsoft.com/office/drawing/2014/main" id="{6944D16A-37C0-8E58-65CE-67E4BD9F7E41}"/>
+              </a:ext>
+            </a:extLst>
+          </p:cNvPr>
+          <p:cNvPicPr>
+            <a:picLocks noChangeAspect="1"/>
+          </p:cNvPicPr>
+          <p:nvPr/>
+        </p:nvPicPr>
+        <p:blipFill>
+          <a:blip r:embed="rId3">
+            <a:extLst>
+              <a:ext uri="{28A0092B-C50C-407E-A947-70E740481C1C}">
+                <a14:useLocalDpi xmlns:a14="http://schemas.microsoft.com/office/drawing/2010/main" val="0"/>
+              </a:ext>
+            </a:extLst>
+          </a:blip>
+          <a:stretch>
+            <a:fillRect/>
+          </a:stretch>
+        </p:blipFill>
+        <p:spPr>
+          <a:xfrm>
+            <a:off x="6359525" y="0"/>
+            <a:ext cx="5751871" cy="6858000"/>
+          </a:xfrm>
+          <a:prstGeom prst="rect">
+            <a:avLst/>
+          </a:prstGeom>
+        </p:spPr>
+      </p:pic>
+      <p:pic>
+        <p:nvPicPr>
+          <p:cNvPr id="10" name="Picture 9" descr="A screen shot of a graph&#10;&#10;Description automatically generated">
+            <a:extLst>
+              <a:ext uri="{FF2B5EF4-FFF2-40B4-BE49-F238E27FC236}">
+                <a16:creationId xmlns:a16="http://schemas.microsoft.com/office/drawing/2014/main" id="{42012E3D-5286-4200-1413-99AB9C444275}"/>
+              </a:ext>
+            </a:extLst>
+          </p:cNvPr>
+          <p:cNvPicPr>
+            <a:picLocks noChangeAspect="1"/>
+          </p:cNvPicPr>
+          <p:nvPr/>
+        </p:nvPicPr>
+        <p:blipFill>
+          <a:blip r:embed="rId4">
+            <a:extLst>
+              <a:ext uri="{28A0092B-C50C-407E-A947-70E740481C1C}">
+                <a14:useLocalDpi xmlns:a14="http://schemas.microsoft.com/office/drawing/2010/main" val="0"/>
+              </a:ext>
+            </a:extLst>
+          </a:blip>
+          <a:stretch>
+            <a:fillRect/>
+          </a:stretch>
+        </p:blipFill>
+        <p:spPr>
+          <a:xfrm>
+            <a:off x="6359524" y="0"/>
+            <a:ext cx="5751871" cy="6858000"/>
+          </a:xfrm>
+          <a:prstGeom prst="rect">
+            <a:avLst/>
+          </a:prstGeom>
+        </p:spPr>
+      </p:pic>
+    </p:spTree>
+    <p:extLst>
+      <p:ext uri="{BB962C8B-B14F-4D97-AF65-F5344CB8AC3E}">
+        <p14:creationId xmlns:p14="http://schemas.microsoft.com/office/powerpoint/2010/main" val="2591613455"/>
+      </p:ext>
+    </p:extLst>
+  </p:cSld>
+  <p:clrMapOvr>
+    <a:masterClrMapping/>
+  </p:clrMapOvr>
+  <mc:AlternateContent xmlns:mc="http://schemas.openxmlformats.org/markup-compatibility/2006" xmlns:p14="http://schemas.microsoft.com/office/powerpoint/2010/main">
+    <mc:Choice Requires="p14">
+      <p:transition spd="med" p14:dur="700">
+        <p:fade/>
+      </p:transition>
+    </mc:Choice>
+    <mc:Fallback xmlns="">
+      <p:transition spd="med">
+        <p:fade/>
+      </p:transition>
+    </mc:Fallback>
+  </mc:AlternateContent>
+  <p:timing>
+    <p:tnLst>
+      <p:par>
+        <p:cTn id="1" dur="indefinite" restart="never" nodeType="tmRoot">
+          <p:childTnLst>
+            <p:seq concurrent="1" nextAc="seek">
+              <p:cTn id="2" dur="indefinite" nodeType="mainSeq">
+                <p:childTnLst>
+                  <p:par>
+                    <p:cTn id="3" fill="hold">
+                      <p:stCondLst>
+                        <p:cond delay="indefinite"/>
+                      </p:stCondLst>
+                      <p:childTnLst>
+                        <p:par>
+                          <p:cTn id="4" fill="hold">
+                            <p:stCondLst>
+                              <p:cond delay="0"/>
+                            </p:stCondLst>
+                            <p:childTnLst>
+                              <p:par>
+                                <p:cTn id="5" presetID="10" presetClass="entr" presetSubtype="0" fill="hold" grpId="0" nodeType="clickEffect">
+                                  <p:stCondLst>
+                                    <p:cond delay="0"/>
+                                  </p:stCondLst>
+                                  <p:childTnLst>
+                                    <p:set>
+                                      <p:cBhvr>
+                                        <p:cTn id="6" dur="1" fill="hold">
+                                          <p:stCondLst>
+                                            <p:cond delay="0"/>
+                                          </p:stCondLst>
+                                        </p:cTn>
+                                        <p:tgtEl>
+                                          <p:spTgt spid="3">
+                                            <p:txEl>
+                                              <p:pRg st="0" end="0"/>
+                                            </p:txEl>
+                                          </p:spTgt>
+                                        </p:tgtEl>
+                                        <p:attrNameLst>
+                                          <p:attrName>style.visibility</p:attrName>
+                                        </p:attrNameLst>
+                                      </p:cBhvr>
+                                      <p:to>
+                                        <p:strVal val="visible"/>
+                                      </p:to>
+                                    </p:set>
+                                    <p:animEffect transition="in" filter="fade">
+                                      <p:cBhvr>
+                                        <p:cTn id="7" dur="500"/>
+                                        <p:tgtEl>
+                                          <p:spTgt spid="3">
+                                            <p:txEl>
+                                              <p:pRg st="0" end="0"/>
+                                            </p:txEl>
+                                          </p:spTgt>
+                                        </p:tgtEl>
+                                      </p:cBhvr>
+                                    </p:animEffect>
+                                  </p:childTnLst>
+                                </p:cTn>
+                              </p:par>
+                            </p:childTnLst>
+                          </p:cTn>
+                        </p:par>
+                      </p:childTnLst>
+                    </p:cTn>
+                  </p:par>
+                  <p:par>
+                    <p:cTn id="8" fill="hold">
+                      <p:stCondLst>
+                        <p:cond delay="indefinite"/>
+                      </p:stCondLst>
+                      <p:childTnLst>
+                        <p:par>
+                          <p:cTn id="9" fill="hold">
+                            <p:stCondLst>
+                              <p:cond delay="0"/>
+                            </p:stCondLst>
+                            <p:childTnLst>
+                              <p:par>
+                                <p:cTn id="10" presetID="10" presetClass="entr" presetSubtype="0" fill="hold" grpId="0" nodeType="clickEffect">
+                                  <p:stCondLst>
+                                    <p:cond delay="0"/>
+                                  </p:stCondLst>
+                                  <p:childTnLst>
+                                    <p:set>
+                                      <p:cBhvr>
+                                        <p:cTn id="11" dur="1" fill="hold">
+                                          <p:stCondLst>
+                                            <p:cond delay="0"/>
+                                          </p:stCondLst>
+                                        </p:cTn>
+                                        <p:tgtEl>
+                                          <p:spTgt spid="3">
+                                            <p:txEl>
+                                              <p:pRg st="1" end="1"/>
+                                            </p:txEl>
+                                          </p:spTgt>
+                                        </p:tgtEl>
+                                        <p:attrNameLst>
+                                          <p:attrName>style.visibility</p:attrName>
+                                        </p:attrNameLst>
+                                      </p:cBhvr>
+                                      <p:to>
+                                        <p:strVal val="visible"/>
+                                      </p:to>
+                                    </p:set>
+                                    <p:animEffect transition="in" filter="fade">
+                                      <p:cBhvr>
+                                        <p:cTn id="12" dur="500"/>
+                                        <p:tgtEl>
+                                          <p:spTgt spid="3">
+                                            <p:txEl>
+                                              <p:pRg st="1" end="1"/>
+                                            </p:txEl>
+                                          </p:spTgt>
+                                        </p:tgtEl>
+                                      </p:cBhvr>
+                                    </p:animEffect>
+                                  </p:childTnLst>
+                                </p:cTn>
+                              </p:par>
+                            </p:childTnLst>
+                          </p:cTn>
+                        </p:par>
+                      </p:childTnLst>
+                    </p:cTn>
+                  </p:par>
+                  <p:par>
+                    <p:cTn id="13" fill="hold">
+                      <p:stCondLst>
+                        <p:cond delay="indefinite"/>
+                      </p:stCondLst>
+                      <p:childTnLst>
+                        <p:par>
+                          <p:cTn id="14" fill="hold">
+                            <p:stCondLst>
+                              <p:cond delay="0"/>
+                            </p:stCondLst>
+                            <p:childTnLst>
+                              <p:par>
+                                <p:cTn id="15" presetID="10" presetClass="entr" presetSubtype="0" fill="hold" grpId="0" nodeType="clickEffect">
+                                  <p:stCondLst>
+                                    <p:cond delay="0"/>
+                                  </p:stCondLst>
+                                  <p:childTnLst>
+                                    <p:set>
+                                      <p:cBhvr>
+                                        <p:cTn id="16" dur="1" fill="hold">
+                                          <p:stCondLst>
+                                            <p:cond delay="0"/>
+                                          </p:stCondLst>
+                                        </p:cTn>
+                                        <p:tgtEl>
+                                          <p:spTgt spid="3">
+                                            <p:txEl>
+                                              <p:pRg st="2" end="2"/>
+                                            </p:txEl>
+                                          </p:spTgt>
+                                        </p:tgtEl>
+                                        <p:attrNameLst>
+                                          <p:attrName>style.visibility</p:attrName>
+                                        </p:attrNameLst>
+                                      </p:cBhvr>
+                                      <p:to>
+                                        <p:strVal val="visible"/>
+                                      </p:to>
+                                    </p:set>
+                                    <p:animEffect transition="in" filter="fade">
+                                      <p:cBhvr>
+                                        <p:cTn id="17" dur="500"/>
+                                        <p:tgtEl>
+                                          <p:spTgt spid="3">
+                                            <p:txEl>
+                                              <p:pRg st="2" end="2"/>
+                                            </p:txEl>
+                                          </p:spTgt>
+                                        </p:tgtEl>
+                                      </p:cBhvr>
+                                    </p:animEffect>
+                                  </p:childTnLst>
+                                </p:cTn>
+                              </p:par>
+                              <p:par>
+                                <p:cTn id="18" presetID="10" presetClass="entr" presetSubtype="0" fill="hold" grpId="0" nodeType="withEffect">
+                                  <p:stCondLst>
+                                    <p:cond delay="0"/>
+                                  </p:stCondLst>
+                                  <p:childTnLst>
+                                    <p:set>
+                                      <p:cBhvr>
+                                        <p:cTn id="19" dur="1" fill="hold">
+                                          <p:stCondLst>
+                                            <p:cond delay="0"/>
+                                          </p:stCondLst>
+                                        </p:cTn>
+                                        <p:tgtEl>
+                                          <p:spTgt spid="3">
+                                            <p:txEl>
+                                              <p:pRg st="3" end="3"/>
+                                            </p:txEl>
+                                          </p:spTgt>
+                                        </p:tgtEl>
+                                        <p:attrNameLst>
+                                          <p:attrName>style.visibility</p:attrName>
+                                        </p:attrNameLst>
+                                      </p:cBhvr>
+                                      <p:to>
+                                        <p:strVal val="visible"/>
+                                      </p:to>
+                                    </p:set>
+                                    <p:animEffect transition="in" filter="fade">
+                                      <p:cBhvr>
+                                        <p:cTn id="20" dur="500"/>
+                                        <p:tgtEl>
+                                          <p:spTgt spid="3">
+                                            <p:txEl>
+                                              <p:pRg st="3" end="3"/>
+                                            </p:txEl>
+                                          </p:spTgt>
+                                        </p:tgtEl>
+                                      </p:cBhvr>
+                                    </p:animEffect>
+                                  </p:childTnLst>
+                                </p:cTn>
+                              </p:par>
+                              <p:par>
+                                <p:cTn id="21" presetID="10" presetClass="entr" presetSubtype="0" fill="hold" nodeType="withEffect">
+                                  <p:stCondLst>
+                                    <p:cond delay="0"/>
+                                  </p:stCondLst>
+                                  <p:childTnLst>
+                                    <p:set>
+                                      <p:cBhvr>
+                                        <p:cTn id="22" dur="1" fill="hold">
+                                          <p:stCondLst>
+                                            <p:cond delay="0"/>
+                                          </p:stCondLst>
+                                        </p:cTn>
+                                        <p:tgtEl>
+                                          <p:spTgt spid="7"/>
+                                        </p:tgtEl>
+                                        <p:attrNameLst>
+                                          <p:attrName>style.visibility</p:attrName>
+                                        </p:attrNameLst>
+                                      </p:cBhvr>
+                                      <p:to>
+                                        <p:strVal val="visible"/>
+                                      </p:to>
+                                    </p:set>
+                                    <p:animEffect transition="in" filter="fade">
+                                      <p:cBhvr>
+                                        <p:cTn id="23" dur="500"/>
+                                        <p:tgtEl>
+                                          <p:spTgt spid="7"/>
+                                        </p:tgtEl>
+                                      </p:cBhvr>
+                                    </p:animEffect>
+                                  </p:childTnLst>
+                                </p:cTn>
+                              </p:par>
+                            </p:childTnLst>
+                          </p:cTn>
+                        </p:par>
+                      </p:childTnLst>
+                    </p:cTn>
+                  </p:par>
+                  <p:par>
+                    <p:cTn id="24" fill="hold">
+                      <p:stCondLst>
+                        <p:cond delay="indefinite"/>
+                      </p:stCondLst>
+                      <p:childTnLst>
+                        <p:par>
+                          <p:cTn id="25" fill="hold">
+                            <p:stCondLst>
+                              <p:cond delay="0"/>
+                            </p:stCondLst>
+                            <p:childTnLst>
+                              <p:par>
+                                <p:cTn id="26" presetID="10" presetClass="entr" presetSubtype="0" fill="hold" grpId="0" nodeType="clickEffect">
+                                  <p:stCondLst>
+                                    <p:cond delay="0"/>
+                                  </p:stCondLst>
+                                  <p:childTnLst>
+                                    <p:set>
+                                      <p:cBhvr>
+                                        <p:cTn id="27" dur="1" fill="hold">
+                                          <p:stCondLst>
+                                            <p:cond delay="0"/>
+                                          </p:stCondLst>
+                                        </p:cTn>
+                                        <p:tgtEl>
+                                          <p:spTgt spid="3">
+                                            <p:txEl>
+                                              <p:pRg st="4" end="4"/>
+                                            </p:txEl>
+                                          </p:spTgt>
+                                        </p:tgtEl>
+                                        <p:attrNameLst>
+                                          <p:attrName>style.visibility</p:attrName>
+                                        </p:attrNameLst>
+                                      </p:cBhvr>
+                                      <p:to>
+                                        <p:strVal val="visible"/>
+                                      </p:to>
+                                    </p:set>
+                                    <p:animEffect transition="in" filter="fade">
+                                      <p:cBhvr>
+                                        <p:cTn id="28" dur="500"/>
+                                        <p:tgtEl>
+                                          <p:spTgt spid="3">
+                                            <p:txEl>
+                                              <p:pRg st="4" end="4"/>
+                                            </p:txEl>
+                                          </p:spTgt>
+                                        </p:tgtEl>
+                                      </p:cBhvr>
+                                    </p:animEffect>
+                                  </p:childTnLst>
+                                </p:cTn>
+                              </p:par>
+                            </p:childTnLst>
+                          </p:cTn>
+                        </p:par>
+                      </p:childTnLst>
+                    </p:cTn>
+                  </p:par>
+                  <p:par>
+                    <p:cTn id="29" fill="hold">
+                      <p:stCondLst>
+                        <p:cond delay="indefinite"/>
+                      </p:stCondLst>
+                      <p:childTnLst>
+                        <p:par>
+                          <p:cTn id="30" fill="hold">
+                            <p:stCondLst>
+                              <p:cond delay="0"/>
+                            </p:stCondLst>
+                            <p:childTnLst>
+                              <p:par>
+                                <p:cTn id="31" presetID="10" presetClass="entr" presetSubtype="0" fill="hold" grpId="0" nodeType="clickEffect">
+                                  <p:stCondLst>
+                                    <p:cond delay="0"/>
+                                  </p:stCondLst>
+                                  <p:childTnLst>
+                                    <p:set>
+                                      <p:cBhvr>
+                                        <p:cTn id="32" dur="1" fill="hold">
+                                          <p:stCondLst>
+                                            <p:cond delay="0"/>
+                                          </p:stCondLst>
+                                        </p:cTn>
+                                        <p:tgtEl>
+                                          <p:spTgt spid="3">
+                                            <p:txEl>
+                                              <p:pRg st="5" end="5"/>
+                                            </p:txEl>
+                                          </p:spTgt>
+                                        </p:tgtEl>
+                                        <p:attrNameLst>
+                                          <p:attrName>style.visibility</p:attrName>
+                                        </p:attrNameLst>
+                                      </p:cBhvr>
+                                      <p:to>
+                                        <p:strVal val="visible"/>
+                                      </p:to>
+                                    </p:set>
+                                    <p:animEffect transition="in" filter="fade">
+                                      <p:cBhvr>
+                                        <p:cTn id="33" dur="500"/>
+                                        <p:tgtEl>
+                                          <p:spTgt spid="3">
+                                            <p:txEl>
+                                              <p:pRg st="5" end="5"/>
+                                            </p:txEl>
+                                          </p:spTgt>
+                                        </p:tgtEl>
+                                      </p:cBhvr>
+                                    </p:animEffect>
+                                  </p:childTnLst>
+                                </p:cTn>
+                              </p:par>
+                            </p:childTnLst>
+                          </p:cTn>
+                        </p:par>
+                      </p:childTnLst>
+                    </p:cTn>
+                  </p:par>
+                  <p:par>
+                    <p:cTn id="34" fill="hold">
+                      <p:stCondLst>
+                        <p:cond delay="indefinite"/>
+                      </p:stCondLst>
+                      <p:childTnLst>
+                        <p:par>
+                          <p:cTn id="35" fill="hold">
+                            <p:stCondLst>
+                              <p:cond delay="0"/>
+                            </p:stCondLst>
+                            <p:childTnLst>
+                              <p:par>
+                                <p:cTn id="36" presetID="10" presetClass="entr" presetSubtype="0" fill="hold" grpId="0" nodeType="clickEffect">
+                                  <p:stCondLst>
+                                    <p:cond delay="0"/>
+                                  </p:stCondLst>
+                                  <p:childTnLst>
+                                    <p:set>
+                                      <p:cBhvr>
+                                        <p:cTn id="37" dur="1" fill="hold">
+                                          <p:stCondLst>
+                                            <p:cond delay="0"/>
+                                          </p:stCondLst>
+                                        </p:cTn>
+                                        <p:tgtEl>
+                                          <p:spTgt spid="3">
+                                            <p:txEl>
+                                              <p:pRg st="6" end="6"/>
+                                            </p:txEl>
+                                          </p:spTgt>
+                                        </p:tgtEl>
+                                        <p:attrNameLst>
+                                          <p:attrName>style.visibility</p:attrName>
+                                        </p:attrNameLst>
+                                      </p:cBhvr>
+                                      <p:to>
+                                        <p:strVal val="visible"/>
+                                      </p:to>
+                                    </p:set>
+                                    <p:animEffect transition="in" filter="fade">
+                                      <p:cBhvr>
+                                        <p:cTn id="38" dur="500"/>
+                                        <p:tgtEl>
+                                          <p:spTgt spid="3">
+                                            <p:txEl>
+                                              <p:pRg st="6" end="6"/>
+                                            </p:txEl>
+                                          </p:spTgt>
+                                        </p:tgtEl>
+                                      </p:cBhvr>
+                                    </p:animEffect>
+                                  </p:childTnLst>
+                                </p:cTn>
+                              </p:par>
+                              <p:par>
+                                <p:cTn id="39" presetID="10" presetClass="entr" presetSubtype="0" fill="hold" nodeType="withEffect">
+                                  <p:stCondLst>
+                                    <p:cond delay="0"/>
+                                  </p:stCondLst>
+                                  <p:childTnLst>
+                                    <p:set>
+                                      <p:cBhvr>
+                                        <p:cTn id="40" dur="1" fill="hold">
+                                          <p:stCondLst>
+                                            <p:cond delay="0"/>
+                                          </p:stCondLst>
+                                        </p:cTn>
+                                        <p:tgtEl>
+                                          <p:spTgt spid="10"/>
+                                        </p:tgtEl>
+                                        <p:attrNameLst>
+                                          <p:attrName>style.visibility</p:attrName>
+                                        </p:attrNameLst>
+                                      </p:cBhvr>
+                                      <p:to>
+                                        <p:strVal val="visible"/>
+                                      </p:to>
+                                    </p:set>
+                                    <p:animEffect transition="in" filter="fade">
+                                      <p:cBhvr>
+                                        <p:cTn id="41" dur="500"/>
+                                        <p:tgtEl>
+                                          <p:spTgt spid="10"/>
+                                        </p:tgtEl>
+                                      </p:cBhvr>
+                                    </p:animEffect>
+                                  </p:childTnLst>
+                                </p:cTn>
+                              </p:par>
+                            </p:childTnLst>
+                          </p:cTn>
+                        </p:par>
+                      </p:childTnLst>
+                    </p:cTn>
+                  </p:par>
+                  <p:par>
+                    <p:cTn id="42" fill="hold">
+                      <p:stCondLst>
+                        <p:cond delay="indefinite"/>
+                      </p:stCondLst>
+                      <p:childTnLst>
+                        <p:par>
+                          <p:cTn id="43" fill="hold">
+                            <p:stCondLst>
+                              <p:cond delay="0"/>
+                            </p:stCondLst>
+                            <p:childTnLst>
+                              <p:par>
+                                <p:cTn id="44" presetID="10" presetClass="entr" presetSubtype="0" fill="hold" grpId="0" nodeType="clickEffect">
+                                  <p:stCondLst>
+                                    <p:cond delay="0"/>
+                                  </p:stCondLst>
+                                  <p:childTnLst>
+                                    <p:set>
+                                      <p:cBhvr>
+                                        <p:cTn id="45" dur="1" fill="hold">
+                                          <p:stCondLst>
+                                            <p:cond delay="0"/>
+                                          </p:stCondLst>
+                                        </p:cTn>
+                                        <p:tgtEl>
+                                          <p:spTgt spid="3">
+                                            <p:txEl>
+                                              <p:pRg st="7" end="7"/>
+                                            </p:txEl>
+                                          </p:spTgt>
+                                        </p:tgtEl>
+                                        <p:attrNameLst>
+                                          <p:attrName>style.visibility</p:attrName>
+                                        </p:attrNameLst>
+                                      </p:cBhvr>
+                                      <p:to>
+                                        <p:strVal val="visible"/>
+                                      </p:to>
+                                    </p:set>
+                                    <p:animEffect transition="in" filter="fade">
+                                      <p:cBhvr>
+                                        <p:cTn id="46" dur="500"/>
+                                        <p:tgtEl>
+                                          <p:spTgt spid="3">
+                                            <p:txEl>
+                                              <p:pRg st="7" end="7"/>
+                                            </p:txEl>
+                                          </p:spTgt>
+                                        </p:tgtEl>
+                                      </p:cBhvr>
+                                    </p:animEffect>
+                                  </p:childTnLst>
+                                </p:cTn>
+                              </p:par>
+                              <p:par>
+                                <p:cTn id="47" presetID="10" presetClass="exit" presetSubtype="0" fill="hold" nodeType="withEffect">
+                                  <p:stCondLst>
+                                    <p:cond delay="0"/>
+                                  </p:stCondLst>
+                                  <p:childTnLst>
+                                    <p:animEffect transition="out" filter="fade">
+                                      <p:cBhvr>
+                                        <p:cTn id="48" dur="500"/>
+                                        <p:tgtEl>
+                                          <p:spTgt spid="7"/>
+                                        </p:tgtEl>
+                                      </p:cBhvr>
+                                    </p:animEffect>
+                                    <p:set>
+                                      <p:cBhvr>
+                                        <p:cTn id="49" dur="1" fill="hold">
+                                          <p:stCondLst>
+                                            <p:cond delay="499"/>
+                                          </p:stCondLst>
+                                        </p:cTn>
+                                        <p:tgtEl>
+                                          <p:spTgt spid="7"/>
+                                        </p:tgtEl>
+                                        <p:attrNameLst>
+                                          <p:attrName>style.visibility</p:attrName>
+                                        </p:attrNameLst>
+                                      </p:cBhvr>
+                                      <p:to>
+                                        <p:strVal val="hidden"/>
+                                      </p:to>
+                                    </p:set>
+                                  </p:childTnLst>
+                                </p:cTn>
+                              </p:par>
+                              <p:par>
+                                <p:cTn id="50" presetID="10" presetClass="exit" presetSubtype="0" fill="hold" nodeType="withEffect">
+                                  <p:stCondLst>
+                                    <p:cond delay="0"/>
+                                  </p:stCondLst>
+                                  <p:childTnLst>
+                                    <p:animEffect transition="out" filter="fade">
+                                      <p:cBhvr>
+                                        <p:cTn id="51" dur="500"/>
+                                        <p:tgtEl>
+                                          <p:spTgt spid="10"/>
+                                        </p:tgtEl>
+                                      </p:cBhvr>
+                                    </p:animEffect>
+                                    <p:set>
+                                      <p:cBhvr>
+                                        <p:cTn id="52" dur="1" fill="hold">
+                                          <p:stCondLst>
+                                            <p:cond delay="499"/>
+                                          </p:stCondLst>
+                                        </p:cTn>
+                                        <p:tgtEl>
+                                          <p:spTgt spid="10"/>
+                                        </p:tgtEl>
+                                        <p:attrNameLst>
+                                          <p:attrName>style.visibility</p:attrName>
+                                        </p:attrNameLst>
+                                      </p:cBhvr>
+                                      <p:to>
+                                        <p:strVal val="hidden"/>
+                                      </p:to>
+                                    </p:set>
+                                  </p:childTnLst>
+                                </p:cTn>
+                              </p:par>
+                            </p:childTnLst>
+                          </p:cTn>
+                        </p:par>
+                      </p:childTnLst>
+                    </p:cTn>
+                  </p:par>
+                </p:childTnLst>
+              </p:cTn>
+              <p:prevCondLst>
+                <p:cond evt="onPrev" delay="0">
+                  <p:tgtEl>
+                    <p:sldTgt/>
+                  </p:tgtEl>
+                </p:cond>
+              </p:prevCondLst>
+              <p:nextCondLst>
+                <p:cond evt="onNext" delay="0">
+                  <p:tgtEl>
+                    <p:sldTgt/>
+                  </p:tgtEl>
+                </p:cond>
+              </p:nextCondLst>
+            </p:seq>
+          </p:childTnLst>
+        </p:cTn>
+      </p:par>
+    </p:tnLst>
+    <p:bldLst>
+      <p:bldP spid="3" grpId="0" uiExpand="1" build="p"/>
+    </p:bldLst>
+  </p:timing>
+</p:sld>
+</file>
+
+<file path=ppt/slides/slide21.xml><?xml version="1.0" encoding="utf-8"?>
 <p:sld xmlns:a="http://schemas.openxmlformats.org/drawingml/2006/main" xmlns:r="http://schemas.openxmlformats.org/officeDocument/2006/relationships" xmlns:p="http://schemas.openxmlformats.org/presentationml/2006/main">
   <p:cSld>
     <p:spTree>
@@ -16960,7 +17159,7 @@
                             </p:stCondLst>
                             <p:childTnLst>
                               <p:par>
-                                <p:cTn id="20" presetID="10" presetClass="entr" presetSubtype="0" fill="hold" grpId="0" nodeType="clickEffect">
+                                <p:cTn id="20" presetID="10" presetClass="entr" presetSubtype="0" fill="hold" nodeType="clickEffect">
                                   <p:stCondLst>
                                     <p:cond delay="0"/>
                                   </p:stCondLst>
@@ -16973,11 +17172,7 @@
                                           </p:stCondLst>
                                         </p:cTn>
                                         <p:tgtEl>
-                                          <p:spTgt spid="3">
-                                            <p:txEl>
-                                              <p:pRg st="3" end="3"/>
-                                            </p:txEl>
-                                          </p:spTgt>
+                                          <p:spTgt spid="15"/>
                                         </p:tgtEl>
                                         <p:attrNameLst>
                                           <p:attrName>style.visibility</p:attrName>
@@ -16991,11 +17186,7 @@
                                       <p:cBhvr>
                                         <p:cTn id="22" dur="500"/>
                                         <p:tgtEl>
-                                          <p:spTgt spid="3">
-                                            <p:txEl>
-                                              <p:pRg st="3" end="3"/>
-                                            </p:txEl>
-                                          </p:spTgt>
+                                          <p:spTgt spid="15"/>
                                         </p:tgtEl>
                                       </p:cBhvr>
                                     </p:animEffect>
@@ -17036,7 +17227,7 @@
                                         <p:tgtEl>
                                           <p:spTgt spid="3">
                                             <p:txEl>
-                                              <p:pRg st="4" end="4"/>
+                                              <p:pRg st="3" end="3"/>
                                             </p:txEl>
                                           </p:spTgt>
                                         </p:tgtEl>
@@ -17054,7 +17245,7 @@
                                         <p:tgtEl>
                                           <p:spTgt spid="3">
                                             <p:txEl>
-                                              <p:pRg st="4" end="4"/>
+                                              <p:pRg st="3" end="3"/>
                                             </p:txEl>
                                           </p:spTgt>
                                         </p:tgtEl>
@@ -17097,7 +17288,7 @@
                                         <p:tgtEl>
                                           <p:spTgt spid="3">
                                             <p:txEl>
-                                              <p:pRg st="5" end="5"/>
+                                              <p:pRg st="4" end="4"/>
                                             </p:txEl>
                                           </p:spTgt>
                                         </p:tgtEl>
@@ -17115,50 +17306,7 @@
                                         <p:tgtEl>
                                           <p:spTgt spid="3">
                                             <p:txEl>
-                                              <p:pRg st="5" end="5"/>
-                                            </p:txEl>
-                                          </p:spTgt>
-                                        </p:tgtEl>
-                                      </p:cBhvr>
-                                    </p:animEffect>
-                                  </p:childTnLst>
-                                </p:cTn>
-                              </p:par>
-                              <p:par>
-                                <p:cTn id="33" presetID="10" presetClass="entr" presetSubtype="0" fill="hold" grpId="0" nodeType="withEffect">
-                                  <p:stCondLst>
-                                    <p:cond delay="0"/>
-                                  </p:stCondLst>
-                                  <p:childTnLst>
-                                    <p:set>
-                                      <p:cBhvr>
-                                        <p:cTn id="34" dur="1" fill="hold">
-                                          <p:stCondLst>
-                                            <p:cond delay="0"/>
-                                          </p:stCondLst>
-                                        </p:cTn>
-                                        <p:tgtEl>
-                                          <p:spTgt spid="3">
-                                            <p:txEl>
-                                              <p:pRg st="6" end="6"/>
-                                            </p:txEl>
-                                          </p:spTgt>
-                                        </p:tgtEl>
-                                        <p:attrNameLst>
-                                          <p:attrName>style.visibility</p:attrName>
-                                        </p:attrNameLst>
-                                      </p:cBhvr>
-                                      <p:to>
-                                        <p:strVal val="visible"/>
-                                      </p:to>
-                                    </p:set>
-                                    <p:animEffect transition="in" filter="fade">
-                                      <p:cBhvr>
-                                        <p:cTn id="35" dur="500"/>
-                                        <p:tgtEl>
-                                          <p:spTgt spid="3">
-                                            <p:txEl>
-                                              <p:pRg st="6" end="6"/>
+                                              <p:pRg st="4" end="4"/>
                                             </p:txEl>
                                           </p:spTgt>
                                         </p:tgtEl>
@@ -17174,25 +17322,68 @@
                     </p:cTn>
                   </p:par>
                   <p:par>
-                    <p:cTn id="36" fill="hold">
+                    <p:cTn id="33" fill="hold">
                       <p:stCondLst>
                         <p:cond delay="indefinite"/>
                       </p:stCondLst>
                       <p:childTnLst>
                         <p:par>
-                          <p:cTn id="37" fill="hold">
+                          <p:cTn id="34" fill="hold">
                             <p:stCondLst>
                               <p:cond delay="0"/>
                             </p:stCondLst>
                             <p:childTnLst>
                               <p:par>
-                                <p:cTn id="38" presetID="10" presetClass="entr" presetSubtype="0" fill="hold" grpId="0" nodeType="clickEffect">
+                                <p:cTn id="35" presetID="10" presetClass="entr" presetSubtype="0" fill="hold" grpId="0" nodeType="clickEffect">
                                   <p:stCondLst>
                                     <p:cond delay="0"/>
                                   </p:stCondLst>
                                   <p:childTnLst>
                                     <p:set>
                                       <p:cBhvr>
+                                        <p:cTn id="36" dur="1" fill="hold">
+                                          <p:stCondLst>
+                                            <p:cond delay="0"/>
+                                          </p:stCondLst>
+                                        </p:cTn>
+                                        <p:tgtEl>
+                                          <p:spTgt spid="3">
+                                            <p:txEl>
+                                              <p:pRg st="5" end="5"/>
+                                            </p:txEl>
+                                          </p:spTgt>
+                                        </p:tgtEl>
+                                        <p:attrNameLst>
+                                          <p:attrName>style.visibility</p:attrName>
+                                        </p:attrNameLst>
+                                      </p:cBhvr>
+                                      <p:to>
+                                        <p:strVal val="visible"/>
+                                      </p:to>
+                                    </p:set>
+                                    <p:animEffect transition="in" filter="fade">
+                                      <p:cBhvr>
+                                        <p:cTn id="37" dur="500"/>
+                                        <p:tgtEl>
+                                          <p:spTgt spid="3">
+                                            <p:txEl>
+                                              <p:pRg st="5" end="5"/>
+                                            </p:txEl>
+                                          </p:spTgt>
+                                        </p:tgtEl>
+                                      </p:cBhvr>
+                                    </p:animEffect>
+                                  </p:childTnLst>
+                                </p:cTn>
+                              </p:par>
+                              <p:par>
+                                <p:cTn id="38" presetID="10" presetClass="entr" presetSubtype="0" fill="hold" grpId="0" nodeType="withEffect">
+                                  <p:stCondLst>
+                                    <p:cond delay="0"/>
+                                  </p:stCondLst>
+                                  <p:childTnLst>
+                                    <p:set>
+                                      <p:cBhvr>
                                         <p:cTn id="39" dur="1" fill="hold">
                                           <p:stCondLst>
                                             <p:cond delay="0"/>
@@ -17201,7 +17392,7 @@
                                         <p:tgtEl>
                                           <p:spTgt spid="3">
                                             <p:txEl>
-                                              <p:pRg st="7" end="7"/>
+                                              <p:pRg st="6" end="6"/>
                                             </p:txEl>
                                           </p:spTgt>
                                         </p:tgtEl>
@@ -17219,7 +17410,7 @@
                                         <p:tgtEl>
                                           <p:spTgt spid="3">
                                             <p:txEl>
-                                              <p:pRg st="7" end="7"/>
+                                              <p:pRg st="6" end="6"/>
                                             </p:txEl>
                                           </p:spTgt>
                                         </p:tgtEl>
@@ -17247,7 +17438,7 @@
                             </p:stCondLst>
                             <p:childTnLst>
                               <p:par>
-                                <p:cTn id="43" presetID="10" presetClass="entr" presetSubtype="0" fill="hold" nodeType="clickEffect">
+                                <p:cTn id="43" presetID="10" presetClass="entr" presetSubtype="0" fill="hold" grpId="0" nodeType="clickEffect">
                                   <p:stCondLst>
                                     <p:cond delay="0"/>
                                   </p:stCondLst>
@@ -17260,7 +17451,11 @@
                                           </p:stCondLst>
                                         </p:cTn>
                                         <p:tgtEl>
-                                          <p:spTgt spid="18"/>
+                                          <p:spTgt spid="3">
+                                            <p:txEl>
+                                              <p:pRg st="7" end="7"/>
+                                            </p:txEl>
+                                          </p:spTgt>
                                         </p:tgtEl>
                                         <p:attrNameLst>
                                           <p:attrName>style.visibility</p:attrName>
@@ -17274,7 +17469,11 @@
                                       <p:cBhvr>
                                         <p:cTn id="45" dur="500"/>
                                         <p:tgtEl>
-                                          <p:spTgt spid="18"/>
+                                          <p:spTgt spid="3">
+                                            <p:txEl>
+                                              <p:pRg st="7" end="7"/>
+                                            </p:txEl>
+                                          </p:spTgt>
                                         </p:tgtEl>
                                       </p:cBhvr>
                                     </p:animEffect>
@@ -17300,14 +17499,67 @@
                             </p:stCondLst>
                             <p:childTnLst>
                               <p:par>
-                                <p:cTn id="48" presetID="10" presetClass="exit" presetSubtype="0" fill="hold" nodeType="clickEffect">
+                                <p:cTn id="48" presetID="10" presetClass="entr" presetSubtype="0" fill="hold" nodeType="clickEffect">
+                                  <p:stCondLst>
+                                    <p:cond delay="0"/>
+                                  </p:stCondLst>
+                                  <p:childTnLst>
+                                    <p:set>
+                                      <p:cBhvr>
+                                        <p:cTn id="49" dur="1" fill="hold">
+                                          <p:stCondLst>
+                                            <p:cond delay="0"/>
+                                          </p:stCondLst>
+                                        </p:cTn>
+                                        <p:tgtEl>
+                                          <p:spTgt spid="18"/>
+                                        </p:tgtEl>
+                                        <p:attrNameLst>
+                                          <p:attrName>style.visibility</p:attrName>
+                                        </p:attrNameLst>
+                                      </p:cBhvr>
+                                      <p:to>
+                                        <p:strVal val="visible"/>
+                                      </p:to>
+                                    </p:set>
+                                    <p:animEffect transition="in" filter="fade">
+                                      <p:cBhvr>
+                                        <p:cTn id="50" dur="500"/>
+                                        <p:tgtEl>
+                                          <p:spTgt spid="18"/>
+                                        </p:tgtEl>
+                                      </p:cBhvr>
+                                    </p:animEffect>
+                                  </p:childTnLst>
+                                </p:cTn>
+                              </p:par>
+                            </p:childTnLst>
+                          </p:cTn>
+                        </p:par>
+                      </p:childTnLst>
+                    </p:cTn>
+                  </p:par>
+                  <p:par>
+                    <p:cTn id="51" fill="hold">
+                      <p:stCondLst>
+                        <p:cond delay="indefinite"/>
+                      </p:stCondLst>
+                      <p:childTnLst>
+                        <p:par>
+                          <p:cTn id="52" fill="hold">
+                            <p:stCondLst>
+                              <p:cond delay="0"/>
+                            </p:stCondLst>
+                            <p:childTnLst>
+                              <p:par>
+                                <p:cTn id="53" presetID="10" presetClass="exit" presetSubtype="0" fill="hold" nodeType="clickEffect">
                                   <p:stCondLst>
                                     <p:cond delay="0"/>
                                   </p:stCondLst>
                                   <p:childTnLst>
                                     <p:animEffect transition="out" filter="fade">
                                       <p:cBhvr>
-                                        <p:cTn id="49" dur="500"/>
+                                        <p:cTn id="54" dur="500"/>
                                         <p:tgtEl>
                                           <p:spTgt spid="18"/>
                                         </p:tgtEl>
@@ -17315,7 +17567,7 @@
                                     </p:animEffect>
                                     <p:set>
                                       <p:cBhvr>
-                                        <p:cTn id="50" dur="1" fill="hold">
+                                        <p:cTn id="55" dur="1" fill="hold">
                                           <p:stCondLst>
                                             <p:cond delay="499"/>
                                           </p:stCondLst>
@@ -17335,14 +17587,14 @@
                                 </p:cTn>
                               </p:par>
                               <p:par>
-                                <p:cTn id="51" presetID="10" presetClass="entr" presetSubtype="0" fill="hold" nodeType="withEffect">
+                                <p:cTn id="56" presetID="10" presetClass="entr" presetSubtype="0" fill="hold" nodeType="withEffect">
                                   <p:stCondLst>
                                     <p:cond delay="0"/>
                                   </p:stCondLst>
                                   <p:childTnLst>
                                     <p:set>
                                       <p:cBhvr>
-                                        <p:cTn id="52" dur="1" fill="hold">
+                                        <p:cTn id="57" dur="1" fill="hold">
                                           <p:stCondLst>
                                             <p:cond delay="0"/>
                                           </p:stCondLst>
@@ -17360,7 +17612,7 @@
                                     </p:set>
                                     <p:animEffect transition="in" filter="fade">
                                       <p:cBhvr>
-                                        <p:cTn id="53" dur="500"/>
+                                        <p:cTn id="58" dur="500"/>
                                         <p:tgtEl>
                                           <p:spTgt spid="21"/>
                                         </p:tgtEl>
@@ -17403,7 +17655,7 @@
 </p:sld>
 </file>
 
-<file path=ppt/slides/slide21.xml><?xml version="1.0" encoding="utf-8"?>
+<file path=ppt/slides/slide22.xml><?xml version="1.0" encoding="utf-8"?>
 <p:sld xmlns:a="http://schemas.openxmlformats.org/drawingml/2006/main" xmlns:r="http://schemas.openxmlformats.org/officeDocument/2006/relationships" xmlns:p="http://schemas.openxmlformats.org/presentationml/2006/main">
   <p:cSld>
     <p:spTree>
@@ -17458,8 +17710,8 @@
           </a:p>
         </p:txBody>
       </p:sp>
-      <mc:AlternateContent xmlns:mc="http://schemas.openxmlformats.org/markup-compatibility/2006" xmlns:a14="http://schemas.microsoft.com/office/drawing/2010/main">
-        <mc:Choice Requires="a14">
+      <mc:AlternateContent xmlns:mc="http://schemas.openxmlformats.org/markup-compatibility/2006">
+        <mc:Choice xmlns:a14="http://schemas.microsoft.com/office/drawing/2010/main" Requires="a14">
           <p:sp>
             <p:nvSpPr>
               <p:cNvPr id="12" name="Content Placeholder 2">
@@ -18141,7 +18393,7 @@
             </p:txBody>
           </p:sp>
         </mc:Choice>
-        <mc:Fallback xmlns="">
+        <mc:Fallback>
           <p:sp>
             <p:nvSpPr>
               <p:cNvPr id="12" name="Content Placeholder 2">
@@ -18780,7 +19032,7 @@
 </p:sld>
 </file>
 
-<file path=ppt/slides/slide22.xml><?xml version="1.0" encoding="utf-8"?>
+<file path=ppt/slides/slide23.xml><?xml version="1.0" encoding="utf-8"?>
 <p:sld xmlns:a="http://schemas.openxmlformats.org/drawingml/2006/main" xmlns:r="http://schemas.openxmlformats.org/officeDocument/2006/relationships" xmlns:p="http://schemas.openxmlformats.org/presentationml/2006/main">
   <p:cSld>
     <p:spTree>
@@ -18857,7 +19109,7 @@
             <a:pPr lvl="1"/>
             <a:r>
               <a:rPr lang="en-GB" dirty="0"/>
-              <a:t>You’ve practiced your whole life, such that you have a 95% chance of getting the hoop on the post</a:t>
+              <a:t>If you use a small hoop, then your chance of hitting the target is small, but if you use a “bigger” hoop you have a 95% chance</a:t>
             </a:r>
           </a:p>
           <a:p>
@@ -19009,15 +19261,33 @@
                                   </p:childTnLst>
                                 </p:cTn>
                               </p:par>
+                            </p:childTnLst>
+                          </p:cTn>
+                        </p:par>
+                      </p:childTnLst>
+                    </p:cTn>
+                  </p:par>
+                  <p:par>
+                    <p:cTn id="8" fill="hold">
+                      <p:stCondLst>
+                        <p:cond delay="indefinite"/>
+                      </p:stCondLst>
+                      <p:childTnLst>
+                        <p:par>
+                          <p:cTn id="9" fill="hold">
+                            <p:stCondLst>
+                              <p:cond delay="0"/>
+                            </p:stCondLst>
+                            <p:childTnLst>
                               <p:par>
-                                <p:cTn id="8" presetID="10" presetClass="entr" presetSubtype="0" fill="hold" grpId="0" nodeType="withEffect">
+                                <p:cTn id="10" presetID="10" presetClass="entr" presetSubtype="0" fill="hold" grpId="0" nodeType="clickEffect">
                                   <p:stCondLst>
                                     <p:cond delay="0"/>
                                   </p:stCondLst>
                                   <p:childTnLst>
                                     <p:set>
                                       <p:cBhvr>
-                                        <p:cTn id="9" dur="1" fill="hold">
+                                        <p:cTn id="11" dur="1" fill="hold">
                                           <p:stCondLst>
                                             <p:cond delay="0"/>
                                           </p:stCondLst>
@@ -19039,54 +19309,11 @@
                                     </p:set>
                                     <p:animEffect transition="in" filter="fade">
                                       <p:cBhvr>
-                                        <p:cTn id="10" dur="500"/>
+                                        <p:cTn id="12" dur="500"/>
                                         <p:tgtEl>
                                           <p:spTgt spid="3">
                                             <p:txEl>
                                               <p:pRg st="1" end="1"/>
-                                            </p:txEl>
-                                          </p:spTgt>
-                                        </p:tgtEl>
-                                      </p:cBhvr>
-                                    </p:animEffect>
-                                  </p:childTnLst>
-                                </p:cTn>
-                              </p:par>
-                              <p:par>
-                                <p:cTn id="11" presetID="10" presetClass="entr" presetSubtype="0" fill="hold" grpId="0" nodeType="withEffect">
-                                  <p:stCondLst>
-                                    <p:cond delay="0"/>
-                                  </p:stCondLst>
-                                  <p:childTnLst>
-                                    <p:set>
-                                      <p:cBhvr>
-                                        <p:cTn id="12" dur="1" fill="hold">
-                                          <p:stCondLst>
-                                            <p:cond delay="0"/>
-                                          </p:stCondLst>
-                                        </p:cTn>
-                                        <p:tgtEl>
-                                          <p:spTgt spid="3">
-                                            <p:txEl>
-                                              <p:pRg st="2" end="2"/>
-                                            </p:txEl>
-                                          </p:spTgt>
-                                        </p:tgtEl>
-                                        <p:attrNameLst>
-                                          <p:attrName>style.visibility</p:attrName>
-                                        </p:attrNameLst>
-                                      </p:cBhvr>
-                                      <p:to>
-                                        <p:strVal val="visible"/>
-                                      </p:to>
-                                    </p:set>
-                                    <p:animEffect transition="in" filter="fade">
-                                      <p:cBhvr>
-                                        <p:cTn id="13" dur="500"/>
-                                        <p:tgtEl>
-                                          <p:spTgt spid="3">
-                                            <p:txEl>
-                                              <p:pRg st="2" end="2"/>
                                             </p:txEl>
                                           </p:spTgt>
                                         </p:tgtEl>
@@ -19102,26 +19329,26 @@
                     </p:cTn>
                   </p:par>
                   <p:par>
-                    <p:cTn id="14" fill="hold">
+                    <p:cTn id="13" fill="hold">
                       <p:stCondLst>
                         <p:cond delay="indefinite"/>
                       </p:stCondLst>
                       <p:childTnLst>
                         <p:par>
-                          <p:cTn id="15" fill="hold">
+                          <p:cTn id="14" fill="hold">
                             <p:stCondLst>
                               <p:cond delay="0"/>
                             </p:stCondLst>
                             <p:childTnLst>
                               <p:par>
-                                <p:cTn id="16" presetID="10" presetClass="entr" presetSubtype="0" fill="hold" grpId="0" nodeType="clickEffect">
+                                <p:cTn id="15" presetID="10" presetClass="entr" presetSubtype="0" fill="hold" grpId="0" nodeType="clickEffect">
                                   <p:stCondLst>
                                     <p:cond delay="0"/>
                                   </p:stCondLst>
                                   <p:childTnLst>
                                     <p:set>
                                       <p:cBhvr>
-                                        <p:cTn id="17" dur="1" fill="hold">
+                                        <p:cTn id="16" dur="1" fill="hold">
                                           <p:stCondLst>
                                             <p:cond delay="0"/>
                                           </p:stCondLst>
@@ -19129,7 +19356,7 @@
                                         <p:tgtEl>
                                           <p:spTgt spid="3">
                                             <p:txEl>
-                                              <p:pRg st="3" end="3"/>
+                                              <p:pRg st="2" end="2"/>
                                             </p:txEl>
                                           </p:spTgt>
                                         </p:tgtEl>
@@ -19143,97 +19370,11 @@
                                     </p:set>
                                     <p:animEffect transition="in" filter="fade">
                                       <p:cBhvr>
-                                        <p:cTn id="18" dur="500"/>
+                                        <p:cTn id="17" dur="500"/>
                                         <p:tgtEl>
                                           <p:spTgt spid="3">
                                             <p:txEl>
-                                              <p:pRg st="3" end="3"/>
-                                            </p:txEl>
-                                          </p:spTgt>
-                                        </p:tgtEl>
-                                      </p:cBhvr>
-                                    </p:animEffect>
-                                  </p:childTnLst>
-                                </p:cTn>
-                              </p:par>
-                              <p:par>
-                                <p:cTn id="19" presetID="10" presetClass="entr" presetSubtype="0" fill="hold" grpId="0" nodeType="withEffect">
-                                  <p:stCondLst>
-                                    <p:cond delay="0"/>
-                                  </p:stCondLst>
-                                  <p:childTnLst>
-                                    <p:set>
-                                      <p:cBhvr>
-                                        <p:cTn id="20" dur="1" fill="hold">
-                                          <p:stCondLst>
-                                            <p:cond delay="0"/>
-                                          </p:stCondLst>
-                                        </p:cTn>
-                                        <p:tgtEl>
-                                          <p:spTgt spid="3">
-                                            <p:txEl>
-                                              <p:pRg st="4" end="4"/>
-                                            </p:txEl>
-                                          </p:spTgt>
-                                        </p:tgtEl>
-                                        <p:attrNameLst>
-                                          <p:attrName>style.visibility</p:attrName>
-                                        </p:attrNameLst>
-                                      </p:cBhvr>
-                                      <p:to>
-                                        <p:strVal val="visible"/>
-                                      </p:to>
-                                    </p:set>
-                                    <p:animEffect transition="in" filter="fade">
-                                      <p:cBhvr>
-                                        <p:cTn id="21" dur="500"/>
-                                        <p:tgtEl>
-                                          <p:spTgt spid="3">
-                                            <p:txEl>
-                                              <p:pRg st="4" end="4"/>
-                                            </p:txEl>
-                                          </p:spTgt>
-                                        </p:tgtEl>
-                                      </p:cBhvr>
-                                    </p:animEffect>
-                                  </p:childTnLst>
-                                </p:cTn>
-                              </p:par>
-                              <p:par>
-                                <p:cTn id="22" presetID="10" presetClass="entr" presetSubtype="0" fill="hold" grpId="0" nodeType="withEffect">
-                                  <p:stCondLst>
-                                    <p:cond delay="0"/>
-                                  </p:stCondLst>
-                                  <p:childTnLst>
-                                    <p:set>
-                                      <p:cBhvr>
-                                        <p:cTn id="23" dur="1" fill="hold">
-                                          <p:stCondLst>
-                                            <p:cond delay="0"/>
-                                          </p:stCondLst>
-                                        </p:cTn>
-                                        <p:tgtEl>
-                                          <p:spTgt spid="3">
-                                            <p:txEl>
-                                              <p:pRg st="5" end="5"/>
-                                            </p:txEl>
-                                          </p:spTgt>
-                                        </p:tgtEl>
-                                        <p:attrNameLst>
-                                          <p:attrName>style.visibility</p:attrName>
-                                        </p:attrNameLst>
-                                      </p:cBhvr>
-                                      <p:to>
-                                        <p:strVal val="visible"/>
-                                      </p:to>
-                                    </p:set>
-                                    <p:animEffect transition="in" filter="fade">
-                                      <p:cBhvr>
-                                        <p:cTn id="24" dur="500"/>
-                                        <p:tgtEl>
-                                          <p:spTgt spid="3">
-                                            <p:txEl>
-                                              <p:pRg st="5" end="5"/>
+                                              <p:pRg st="2" end="2"/>
                                             </p:txEl>
                                           </p:spTgt>
                                         </p:tgtEl>
@@ -19249,26 +19390,26 @@
                     </p:cTn>
                   </p:par>
                   <p:par>
-                    <p:cTn id="25" fill="hold">
+                    <p:cTn id="18" fill="hold">
                       <p:stCondLst>
                         <p:cond delay="indefinite"/>
                       </p:stCondLst>
                       <p:childTnLst>
                         <p:par>
-                          <p:cTn id="26" fill="hold">
+                          <p:cTn id="19" fill="hold">
                             <p:stCondLst>
                               <p:cond delay="0"/>
                             </p:stCondLst>
                             <p:childTnLst>
                               <p:par>
-                                <p:cTn id="27" presetID="10" presetClass="entr" presetSubtype="0" fill="hold" grpId="0" nodeType="clickEffect">
+                                <p:cTn id="20" presetID="10" presetClass="entr" presetSubtype="0" fill="hold" grpId="0" nodeType="clickEffect">
                                   <p:stCondLst>
                                     <p:cond delay="0"/>
                                   </p:stCondLst>
                                   <p:childTnLst>
                                     <p:set>
                                       <p:cBhvr>
-                                        <p:cTn id="28" dur="1" fill="hold">
+                                        <p:cTn id="21" dur="1" fill="hold">
                                           <p:stCondLst>
                                             <p:cond delay="0"/>
                                           </p:stCondLst>
@@ -19276,7 +19417,7 @@
                                         <p:tgtEl>
                                           <p:spTgt spid="3">
                                             <p:txEl>
-                                              <p:pRg st="6" end="6"/>
+                                              <p:pRg st="3" end="3"/>
                                             </p:txEl>
                                           </p:spTgt>
                                         </p:tgtEl>
@@ -19290,7 +19431,190 @@
                                     </p:set>
                                     <p:animEffect transition="in" filter="fade">
                                       <p:cBhvr>
-                                        <p:cTn id="29" dur="500"/>
+                                        <p:cTn id="22" dur="500"/>
+                                        <p:tgtEl>
+                                          <p:spTgt spid="3">
+                                            <p:txEl>
+                                              <p:pRg st="3" end="3"/>
+                                            </p:txEl>
+                                          </p:spTgt>
+                                        </p:tgtEl>
+                                      </p:cBhvr>
+                                    </p:animEffect>
+                                  </p:childTnLst>
+                                </p:cTn>
+                              </p:par>
+                            </p:childTnLst>
+                          </p:cTn>
+                        </p:par>
+                      </p:childTnLst>
+                    </p:cTn>
+                  </p:par>
+                  <p:par>
+                    <p:cTn id="23" fill="hold">
+                      <p:stCondLst>
+                        <p:cond delay="indefinite"/>
+                      </p:stCondLst>
+                      <p:childTnLst>
+                        <p:par>
+                          <p:cTn id="24" fill="hold">
+                            <p:stCondLst>
+                              <p:cond delay="0"/>
+                            </p:stCondLst>
+                            <p:childTnLst>
+                              <p:par>
+                                <p:cTn id="25" presetID="10" presetClass="entr" presetSubtype="0" fill="hold" grpId="0" nodeType="clickEffect">
+                                  <p:stCondLst>
+                                    <p:cond delay="0"/>
+                                  </p:stCondLst>
+                                  <p:childTnLst>
+                                    <p:set>
+                                      <p:cBhvr>
+                                        <p:cTn id="26" dur="1" fill="hold">
+                                          <p:stCondLst>
+                                            <p:cond delay="0"/>
+                                          </p:stCondLst>
+                                        </p:cTn>
+                                        <p:tgtEl>
+                                          <p:spTgt spid="3">
+                                            <p:txEl>
+                                              <p:pRg st="4" end="4"/>
+                                            </p:txEl>
+                                          </p:spTgt>
+                                        </p:tgtEl>
+                                        <p:attrNameLst>
+                                          <p:attrName>style.visibility</p:attrName>
+                                        </p:attrNameLst>
+                                      </p:cBhvr>
+                                      <p:to>
+                                        <p:strVal val="visible"/>
+                                      </p:to>
+                                    </p:set>
+                                    <p:animEffect transition="in" filter="fade">
+                                      <p:cBhvr>
+                                        <p:cTn id="27" dur="500"/>
+                                        <p:tgtEl>
+                                          <p:spTgt spid="3">
+                                            <p:txEl>
+                                              <p:pRg st="4" end="4"/>
+                                            </p:txEl>
+                                          </p:spTgt>
+                                        </p:tgtEl>
+                                      </p:cBhvr>
+                                    </p:animEffect>
+                                  </p:childTnLst>
+                                </p:cTn>
+                              </p:par>
+                            </p:childTnLst>
+                          </p:cTn>
+                        </p:par>
+                      </p:childTnLst>
+                    </p:cTn>
+                  </p:par>
+                  <p:par>
+                    <p:cTn id="28" fill="hold">
+                      <p:stCondLst>
+                        <p:cond delay="indefinite"/>
+                      </p:stCondLst>
+                      <p:childTnLst>
+                        <p:par>
+                          <p:cTn id="29" fill="hold">
+                            <p:stCondLst>
+                              <p:cond delay="0"/>
+                            </p:stCondLst>
+                            <p:childTnLst>
+                              <p:par>
+                                <p:cTn id="30" presetID="10" presetClass="entr" presetSubtype="0" fill="hold" grpId="0" nodeType="clickEffect">
+                                  <p:stCondLst>
+                                    <p:cond delay="0"/>
+                                  </p:stCondLst>
+                                  <p:childTnLst>
+                                    <p:set>
+                                      <p:cBhvr>
+                                        <p:cTn id="31" dur="1" fill="hold">
+                                          <p:stCondLst>
+                                            <p:cond delay="0"/>
+                                          </p:stCondLst>
+                                        </p:cTn>
+                                        <p:tgtEl>
+                                          <p:spTgt spid="3">
+                                            <p:txEl>
+                                              <p:pRg st="5" end="5"/>
+                                            </p:txEl>
+                                          </p:spTgt>
+                                        </p:tgtEl>
+                                        <p:attrNameLst>
+                                          <p:attrName>style.visibility</p:attrName>
+                                        </p:attrNameLst>
+                                      </p:cBhvr>
+                                      <p:to>
+                                        <p:strVal val="visible"/>
+                                      </p:to>
+                                    </p:set>
+                                    <p:animEffect transition="in" filter="fade">
+                                      <p:cBhvr>
+                                        <p:cTn id="32" dur="500"/>
+                                        <p:tgtEl>
+                                          <p:spTgt spid="3">
+                                            <p:txEl>
+                                              <p:pRg st="5" end="5"/>
+                                            </p:txEl>
+                                          </p:spTgt>
+                                        </p:tgtEl>
+                                      </p:cBhvr>
+                                    </p:animEffect>
+                                  </p:childTnLst>
+                                </p:cTn>
+                              </p:par>
+                            </p:childTnLst>
+                          </p:cTn>
+                        </p:par>
+                      </p:childTnLst>
+                    </p:cTn>
+                  </p:par>
+                  <p:par>
+                    <p:cTn id="33" fill="hold">
+                      <p:stCondLst>
+                        <p:cond delay="indefinite"/>
+                      </p:stCondLst>
+                      <p:childTnLst>
+                        <p:par>
+                          <p:cTn id="34" fill="hold">
+                            <p:stCondLst>
+                              <p:cond delay="0"/>
+                            </p:stCondLst>
+                            <p:childTnLst>
+                              <p:par>
+                                <p:cTn id="35" presetID="10" presetClass="entr" presetSubtype="0" fill="hold" grpId="0" nodeType="clickEffect">
+                                  <p:stCondLst>
+                                    <p:cond delay="0"/>
+                                  </p:stCondLst>
+                                  <p:childTnLst>
+                                    <p:set>
+                                      <p:cBhvr>
+                                        <p:cTn id="36" dur="1" fill="hold">
+                                          <p:stCondLst>
+                                            <p:cond delay="0"/>
+                                          </p:stCondLst>
+                                        </p:cTn>
+                                        <p:tgtEl>
+                                          <p:spTgt spid="3">
+                                            <p:txEl>
+                                              <p:pRg st="6" end="6"/>
+                                            </p:txEl>
+                                          </p:spTgt>
+                                        </p:tgtEl>
+                                        <p:attrNameLst>
+                                          <p:attrName>style.visibility</p:attrName>
+                                        </p:attrNameLst>
+                                      </p:cBhvr>
+                                      <p:to>
+                                        <p:strVal val="visible"/>
+                                      </p:to>
+                                    </p:set>
+                                    <p:animEffect transition="in" filter="fade">
+                                      <p:cBhvr>
+                                        <p:cTn id="37" dur="500"/>
                                         <p:tgtEl>
                                           <p:spTgt spid="3">
                                             <p:txEl>
@@ -19304,14 +19628,14 @@
                                 </p:cTn>
                               </p:par>
                               <p:par>
-                                <p:cTn id="30" presetID="10" presetClass="entr" presetSubtype="0" fill="hold" grpId="0" nodeType="withEffect">
+                                <p:cTn id="38" presetID="10" presetClass="entr" presetSubtype="0" fill="hold" grpId="0" nodeType="withEffect">
                                   <p:stCondLst>
                                     <p:cond delay="0"/>
                                   </p:stCondLst>
                                   <p:childTnLst>
                                     <p:set>
                                       <p:cBhvr>
-                                        <p:cTn id="31" dur="1" fill="hold">
+                                        <p:cTn id="39" dur="1" fill="hold">
                                           <p:stCondLst>
                                             <p:cond delay="0"/>
                                           </p:stCondLst>
@@ -19333,7 +19657,7 @@
                                     </p:set>
                                     <p:animEffect transition="in" filter="fade">
                                       <p:cBhvr>
-                                        <p:cTn id="32" dur="500"/>
+                                        <p:cTn id="40" dur="500"/>
                                         <p:tgtEl>
                                           <p:spTgt spid="3">
                                             <p:txEl>
@@ -19374,13 +19698,13 @@
       </p:par>
     </p:tnLst>
     <p:bldLst>
-      <p:bldP spid="3" grpId="0" build="p"/>
+      <p:bldP spid="3" grpId="0" uiExpand="1" build="p"/>
     </p:bldLst>
   </p:timing>
 </p:sld>
 </file>
 
-<file path=ppt/slides/slide23.xml><?xml version="1.0" encoding="utf-8"?>
+<file path=ppt/slides/slide24.xml><?xml version="1.0" encoding="utf-8"?>
 <p:sld xmlns:a="http://schemas.openxmlformats.org/drawingml/2006/main" xmlns:r="http://schemas.openxmlformats.org/officeDocument/2006/relationships" xmlns:p="http://schemas.openxmlformats.org/presentationml/2006/main">
   <p:cSld>
     <p:spTree>
@@ -19882,7 +20206,7 @@
 </p:sld>
 </file>
 
-<file path=ppt/slides/slide24.xml><?xml version="1.0" encoding="utf-8"?>
+<file path=ppt/slides/slide25.xml><?xml version="1.0" encoding="utf-8"?>
 <p:sld xmlns:a="http://schemas.openxmlformats.org/drawingml/2006/main" xmlns:r="http://schemas.openxmlformats.org/officeDocument/2006/relationships" xmlns:p="http://schemas.openxmlformats.org/presentationml/2006/main">
   <p:cSld>
     <p:spTree>
@@ -20380,7 +20704,7 @@
 </p:sld>
 </file>
 
-<file path=ppt/slides/slide25.xml><?xml version="1.0" encoding="utf-8"?>
+<file path=ppt/slides/slide26.xml><?xml version="1.0" encoding="utf-8"?>
 <p:sld xmlns:a="http://schemas.openxmlformats.org/drawingml/2006/main" xmlns:r="http://schemas.openxmlformats.org/officeDocument/2006/relationships" xmlns:p="http://schemas.openxmlformats.org/presentationml/2006/main">
   <p:cSld>
     <p:spTree>
@@ -20468,7 +20792,20 @@
           <a:p>
             <a:r>
               <a:rPr lang="en-GB" dirty="0"/>
-              <a:t>Probably, but it’s not impossible they have the same average horn length.</a:t>
+              <a:t>When making inference consider both the “point estimate” and the uncertainty</a:t>
+            </a:r>
+          </a:p>
+          <a:p>
+            <a:r>
+              <a:rPr lang="en-GB" dirty="0"/>
+              <a:t>My interpretation:</a:t>
+            </a:r>
+          </a:p>
+          <a:p>
+            <a:pPr lvl="1"/>
+            <a:r>
+              <a:rPr lang="en-GB" dirty="0"/>
+              <a:t>Hunting probably effects horn length, but it’s not impossible that it hunting doesn’t effect horn length.</a:t>
             </a:r>
           </a:p>
         </p:txBody>
@@ -20686,21 +21023,43 @@
                                   </p:childTnLst>
                                 </p:cTn>
                               </p:par>
+                            </p:childTnLst>
+                          </p:cTn>
+                        </p:par>
+                      </p:childTnLst>
+                    </p:cTn>
+                  </p:par>
+                  <p:par>
+                    <p:cTn id="13" fill="hold">
+                      <p:stCondLst>
+                        <p:cond delay="indefinite"/>
+                      </p:stCondLst>
+                      <p:childTnLst>
+                        <p:par>
+                          <p:cTn id="14" fill="hold">
+                            <p:stCondLst>
+                              <p:cond delay="0"/>
+                            </p:stCondLst>
+                            <p:childTnLst>
                               <p:par>
-                                <p:cTn id="13" presetID="10" presetClass="entr" presetSubtype="0" fill="hold" nodeType="withEffect">
+                                <p:cTn id="15" presetID="10" presetClass="entr" presetSubtype="0" fill="hold" grpId="0" nodeType="clickEffect">
                                   <p:stCondLst>
                                     <p:cond delay="0"/>
                                   </p:stCondLst>
                                   <p:childTnLst>
                                     <p:set>
                                       <p:cBhvr>
-                                        <p:cTn id="14" dur="1" fill="hold">
+                                        <p:cTn id="16" dur="1" fill="hold">
                                           <p:stCondLst>
                                             <p:cond delay="0"/>
                                           </p:stCondLst>
                                         </p:cTn>
                                         <p:tgtEl>
-                                          <p:spTgt spid="7"/>
+                                          <p:spTgt spid="3">
+                                            <p:txEl>
+                                              <p:pRg st="2" end="2"/>
+                                            </p:txEl>
+                                          </p:spTgt>
                                         </p:tgtEl>
                                         <p:attrNameLst>
                                           <p:attrName>style.visibility</p:attrName>
@@ -20712,7 +21071,46 @@
                                     </p:set>
                                     <p:animEffect transition="in" filter="fade">
                                       <p:cBhvr>
-                                        <p:cTn id="15" dur="500"/>
+                                        <p:cTn id="17" dur="500"/>
+                                        <p:tgtEl>
+                                          <p:spTgt spid="3">
+                                            <p:txEl>
+                                              <p:pRg st="2" end="2"/>
+                                            </p:txEl>
+                                          </p:spTgt>
+                                        </p:tgtEl>
+                                      </p:cBhvr>
+                                    </p:animEffect>
+                                  </p:childTnLst>
+                                </p:cTn>
+                              </p:par>
+                              <p:par>
+                                <p:cTn id="18" presetID="10" presetClass="entr" presetSubtype="0" fill="hold" nodeType="withEffect">
+                                  <p:stCondLst>
+                                    <p:cond delay="0"/>
+                                  </p:stCondLst>
+                                  <p:childTnLst>
+                                    <p:set>
+                                      <p:cBhvr>
+                                        <p:cTn id="19" dur="1" fill="hold">
+                                          <p:stCondLst>
+                                            <p:cond delay="0"/>
+                                          </p:stCondLst>
+                                        </p:cTn>
+                                        <p:tgtEl>
+                                          <p:spTgt spid="7"/>
+                                        </p:tgtEl>
+                                        <p:attrNameLst>
+                                          <p:attrName>style.visibility</p:attrName>
+                                        </p:attrNameLst>
+                                      </p:cBhvr>
+                                      <p:to>
+                                        <p:strVal val="visible"/>
+                                      </p:to>
+                                    </p:set>
+                                    <p:animEffect transition="in" filter="fade">
+                                      <p:cBhvr>
+                                        <p:cTn id="20" dur="500"/>
                                         <p:tgtEl>
                                           <p:spTgt spid="7"/>
                                         </p:tgtEl>
@@ -20728,26 +21126,26 @@
                     </p:cTn>
                   </p:par>
                   <p:par>
-                    <p:cTn id="16" fill="hold">
+                    <p:cTn id="21" fill="hold">
                       <p:stCondLst>
                         <p:cond delay="indefinite"/>
                       </p:stCondLst>
                       <p:childTnLst>
                         <p:par>
-                          <p:cTn id="17" fill="hold">
+                          <p:cTn id="22" fill="hold">
                             <p:stCondLst>
                               <p:cond delay="0"/>
                             </p:stCondLst>
                             <p:childTnLst>
                               <p:par>
-                                <p:cTn id="18" presetID="10" presetClass="entr" presetSubtype="0" fill="hold" grpId="0" nodeType="clickEffect">
+                                <p:cTn id="23" presetID="10" presetClass="entr" presetSubtype="0" fill="hold" grpId="0" nodeType="clickEffect">
                                   <p:stCondLst>
                                     <p:cond delay="0"/>
                                   </p:stCondLst>
                                   <p:childTnLst>
                                     <p:set>
                                       <p:cBhvr>
-                                        <p:cTn id="19" dur="1" fill="hold">
+                                        <p:cTn id="24" dur="1" fill="hold">
                                           <p:stCondLst>
                                             <p:cond delay="0"/>
                                           </p:stCondLst>
@@ -20755,7 +21153,7 @@
                                         <p:tgtEl>
                                           <p:spTgt spid="3">
                                             <p:txEl>
-                                              <p:pRg st="2" end="2"/>
+                                              <p:pRg st="3" end="3"/>
                                             </p:txEl>
                                           </p:spTgt>
                                         </p:tgtEl>
@@ -20769,11 +21167,54 @@
                                     </p:set>
                                     <p:animEffect transition="in" filter="fade">
                                       <p:cBhvr>
-                                        <p:cTn id="20" dur="500"/>
+                                        <p:cTn id="25" dur="500"/>
                                         <p:tgtEl>
                                           <p:spTgt spid="3">
                                             <p:txEl>
-                                              <p:pRg st="2" end="2"/>
+                                              <p:pRg st="3" end="3"/>
+                                            </p:txEl>
+                                          </p:spTgt>
+                                        </p:tgtEl>
+                                      </p:cBhvr>
+                                    </p:animEffect>
+                                  </p:childTnLst>
+                                </p:cTn>
+                              </p:par>
+                              <p:par>
+                                <p:cTn id="26" presetID="10" presetClass="entr" presetSubtype="0" fill="hold" grpId="0" nodeType="withEffect">
+                                  <p:stCondLst>
+                                    <p:cond delay="0"/>
+                                  </p:stCondLst>
+                                  <p:childTnLst>
+                                    <p:set>
+                                      <p:cBhvr>
+                                        <p:cTn id="27" dur="1" fill="hold">
+                                          <p:stCondLst>
+                                            <p:cond delay="0"/>
+                                          </p:stCondLst>
+                                        </p:cTn>
+                                        <p:tgtEl>
+                                          <p:spTgt spid="3">
+                                            <p:txEl>
+                                              <p:pRg st="4" end="4"/>
+                                            </p:txEl>
+                                          </p:spTgt>
+                                        </p:tgtEl>
+                                        <p:attrNameLst>
+                                          <p:attrName>style.visibility</p:attrName>
+                                        </p:attrNameLst>
+                                      </p:cBhvr>
+                                      <p:to>
+                                        <p:strVal val="visible"/>
+                                      </p:to>
+                                    </p:set>
+                                    <p:animEffect transition="in" filter="fade">
+                                      <p:cBhvr>
+                                        <p:cTn id="28" dur="500"/>
+                                        <p:tgtEl>
+                                          <p:spTgt spid="3">
+                                            <p:txEl>
+                                              <p:pRg st="4" end="4"/>
                                             </p:txEl>
                                           </p:spTgt>
                                         </p:tgtEl>
@@ -20816,7 +21257,7 @@
 </p:sld>
 </file>
 
-<file path=ppt/slides/slide26.xml><?xml version="1.0" encoding="utf-8"?>
+<file path=ppt/slides/slide27.xml><?xml version="1.0" encoding="utf-8"?>
 <p:sld xmlns:a="http://schemas.openxmlformats.org/drawingml/2006/main" xmlns:r="http://schemas.openxmlformats.org/officeDocument/2006/relationships" xmlns:p="http://schemas.openxmlformats.org/presentationml/2006/main">
   <p:cSld>
     <p:spTree>
@@ -20875,7 +21316,7 @@
 </p:sld>
 </file>
 
-<file path=ppt/slides/slide27.xml><?xml version="1.0" encoding="utf-8"?>
+<file path=ppt/slides/slide28.xml><?xml version="1.0" encoding="utf-8"?>
 <p:sld xmlns:a="http://schemas.openxmlformats.org/drawingml/2006/main" xmlns:r="http://schemas.openxmlformats.org/officeDocument/2006/relationships" xmlns:p="http://schemas.openxmlformats.org/presentationml/2006/main">
   <p:cSld>
     <p:spTree>
@@ -22149,7 +22590,7 @@
                                           </p:stCondLst>
                                         </p:cTn>
                                         <p:tgtEl>
-                                          <p:spTgt spid="13"/>
+                                          <p:spTgt spid="14"/>
                                         </p:tgtEl>
                                         <p:attrNameLst>
                                           <p:attrName>style.visibility</p:attrName>
@@ -22163,28 +22604,46 @@
                                       <p:cBhvr>
                                         <p:cTn id="76" dur="500"/>
                                         <p:tgtEl>
-                                          <p:spTgt spid="13"/>
+                                          <p:spTgt spid="14"/>
                                         </p:tgtEl>
                                       </p:cBhvr>
                                     </p:animEffect>
                                   </p:childTnLst>
                                 </p:cTn>
                               </p:par>
+                            </p:childTnLst>
+                          </p:cTn>
+                        </p:par>
+                      </p:childTnLst>
+                    </p:cTn>
+                  </p:par>
+                  <p:par>
+                    <p:cTn id="77" fill="hold">
+                      <p:stCondLst>
+                        <p:cond delay="indefinite"/>
+                      </p:stCondLst>
+                      <p:childTnLst>
+                        <p:par>
+                          <p:cTn id="78" fill="hold">
+                            <p:stCondLst>
+                              <p:cond delay="0"/>
+                            </p:stCondLst>
+                            <p:childTnLst>
                               <p:par>
-                                <p:cTn id="77" presetID="10" presetClass="entr" presetSubtype="0" fill="hold" grpId="0" nodeType="withEffect">
+                                <p:cTn id="79" presetID="10" presetClass="entr" presetSubtype="0" fill="hold" grpId="0" nodeType="clickEffect">
                                   <p:stCondLst>
                                     <p:cond delay="0"/>
                                   </p:stCondLst>
                                   <p:childTnLst>
                                     <p:set>
                                       <p:cBhvr>
-                                        <p:cTn id="78" dur="1" fill="hold">
+                                        <p:cTn id="80" dur="1" fill="hold">
                                           <p:stCondLst>
                                             <p:cond delay="0"/>
                                           </p:stCondLst>
                                         </p:cTn>
                                         <p:tgtEl>
-                                          <p:spTgt spid="14"/>
+                                          <p:spTgt spid="13"/>
                                         </p:tgtEl>
                                         <p:attrNameLst>
                                           <p:attrName>style.visibility</p:attrName>
@@ -22196,9 +22655,9 @@
                                     </p:set>
                                     <p:animEffect transition="in" filter="fade">
                                       <p:cBhvr>
-                                        <p:cTn id="79" dur="500"/>
-                                        <p:tgtEl>
-                                          <p:spTgt spid="14"/>
+                                        <p:cTn id="81" dur="500"/>
+                                        <p:tgtEl>
+                                          <p:spTgt spid="13"/>
                                         </p:tgtEl>
                                       </p:cBhvr>
                                     </p:animEffect>
@@ -22242,7 +22701,7 @@
 </p:sld>
 </file>
 
-<file path=ppt/slides/slide28.xml><?xml version="1.0" encoding="utf-8"?>
+<file path=ppt/slides/slide29.xml><?xml version="1.0" encoding="utf-8"?>
 <p:sld xmlns:a="http://schemas.openxmlformats.org/drawingml/2006/main" xmlns:r="http://schemas.openxmlformats.org/officeDocument/2006/relationships" xmlns:p="http://schemas.openxmlformats.org/presentationml/2006/main">
   <p:cSld>
     <p:spTree>
@@ -22289,8 +22748,8 @@
           </a:p>
         </p:txBody>
       </p:sp>
-      <mc:AlternateContent xmlns:mc="http://schemas.openxmlformats.org/markup-compatibility/2006" xmlns:a14="http://schemas.microsoft.com/office/drawing/2010/main">
-        <mc:Choice Requires="a14">
+      <mc:AlternateContent xmlns:mc="http://schemas.openxmlformats.org/markup-compatibility/2006">
+        <mc:Choice xmlns:a14="http://schemas.microsoft.com/office/drawing/2010/main" Requires="a14">
           <p:sp>
             <p:nvSpPr>
               <p:cNvPr id="3" name="Content Placeholder 2">
@@ -22504,7 +22963,7 @@
               <a:p>
                 <a:r>
                   <a:rPr lang="en-GB" dirty="0"/>
-                  <a:t>For linear models with continuous variables, we estimate an intercept (</a:t>
+                  <a:t>For linear models with a categorical variable, we estimate an intercept (</a:t>
                 </a:r>
                 <a14:m>
                   <m:oMath xmlns:m="http://schemas.openxmlformats.org/officeDocument/2006/math">
@@ -22537,7 +22996,7 @@
                 </a14:m>
                 <a:r>
                   <a:rPr lang="en-GB" dirty="0"/>
-                  <a:t>) and a slope (</a:t>
+                  <a:t>) and contrast treatments (</a:t>
                 </a:r>
                 <a14:m>
                   <m:oMath xmlns:m="http://schemas.openxmlformats.org/officeDocument/2006/math">
@@ -22566,6 +23025,24 @@
                         </m:r>
                       </m:sub>
                     </m:sSub>
+                    <m:r>
+                      <a:rPr lang="en-GB" b="0" i="1" smtClean="0">
+                        <a:latin typeface="Cambria Math" panose="02040503050406030204" pitchFamily="18" charset="0"/>
+                      </a:rPr>
+                      <m:t>, </m:t>
+                    </m:r>
+                    <m:r>
+                      <a:rPr lang="en-GB" b="0" i="1" smtClean="0">
+                        <a:latin typeface="Cambria Math" panose="02040503050406030204" pitchFamily="18" charset="0"/>
+                      </a:rPr>
+                      <m:t>𝑒𝑡𝑐</m:t>
+                    </m:r>
+                    <m:r>
+                      <a:rPr lang="en-GB" b="0" i="1" smtClean="0">
+                        <a:latin typeface="Cambria Math" panose="02040503050406030204" pitchFamily="18" charset="0"/>
+                      </a:rPr>
+                      <m:t>.</m:t>
+                    </m:r>
                   </m:oMath>
                 </a14:m>
                 <a:r>
@@ -22595,7 +23072,7 @@
             </p:txBody>
           </p:sp>
         </mc:Choice>
-        <mc:Fallback xmlns="">
+        <mc:Fallback>
           <p:sp>
             <p:nvSpPr>
               <p:cNvPr id="3" name="Content Placeholder 2">
@@ -22650,6 +23127,463 @@
   <p:clrMapOvr>
     <a:masterClrMapping/>
   </p:clrMapOvr>
+  <p:timing>
+    <p:tnLst>
+      <p:par>
+        <p:cTn id="1" dur="indefinite" restart="never" nodeType="tmRoot">
+          <p:childTnLst>
+            <p:seq concurrent="1" nextAc="seek">
+              <p:cTn id="2" dur="indefinite" nodeType="mainSeq">
+                <p:childTnLst>
+                  <p:par>
+                    <p:cTn id="3" fill="hold">
+                      <p:stCondLst>
+                        <p:cond delay="indefinite"/>
+                      </p:stCondLst>
+                      <p:childTnLst>
+                        <p:par>
+                          <p:cTn id="4" fill="hold">
+                            <p:stCondLst>
+                              <p:cond delay="0"/>
+                            </p:stCondLst>
+                            <p:childTnLst>
+                              <p:par>
+                                <p:cTn id="5" presetID="10" presetClass="entr" presetSubtype="0" fill="hold" nodeType="clickEffect">
+                                  <p:stCondLst>
+                                    <p:cond delay="0"/>
+                                  </p:stCondLst>
+                                  <p:childTnLst>
+                                    <p:set>
+                                      <p:cBhvr>
+                                        <p:cTn id="6" dur="1" fill="hold">
+                                          <p:stCondLst>
+                                            <p:cond delay="0"/>
+                                          </p:stCondLst>
+                                        </p:cTn>
+                                        <p:tgtEl>
+                                          <p:spTgt spid="3">
+                                            <p:txEl>
+                                              <p:pRg st="0" end="0"/>
+                                            </p:txEl>
+                                          </p:spTgt>
+                                        </p:tgtEl>
+                                        <p:attrNameLst>
+                                          <p:attrName>style.visibility</p:attrName>
+                                        </p:attrNameLst>
+                                      </p:cBhvr>
+                                      <p:to>
+                                        <p:strVal val="visible"/>
+                                      </p:to>
+                                    </p:set>
+                                    <p:animEffect transition="in" filter="fade">
+                                      <p:cBhvr>
+                                        <p:cTn id="7" dur="500"/>
+                                        <p:tgtEl>
+                                          <p:spTgt spid="3">
+                                            <p:txEl>
+                                              <p:pRg st="0" end="0"/>
+                                            </p:txEl>
+                                          </p:spTgt>
+                                        </p:tgtEl>
+                                      </p:cBhvr>
+                                    </p:animEffect>
+                                  </p:childTnLst>
+                                </p:cTn>
+                              </p:par>
+                            </p:childTnLst>
+                          </p:cTn>
+                        </p:par>
+                      </p:childTnLst>
+                    </p:cTn>
+                  </p:par>
+                  <p:par>
+                    <p:cTn id="8" fill="hold">
+                      <p:stCondLst>
+                        <p:cond delay="indefinite"/>
+                      </p:stCondLst>
+                      <p:childTnLst>
+                        <p:par>
+                          <p:cTn id="9" fill="hold">
+                            <p:stCondLst>
+                              <p:cond delay="0"/>
+                            </p:stCondLst>
+                            <p:childTnLst>
+                              <p:par>
+                                <p:cTn id="10" presetID="10" presetClass="entr" presetSubtype="0" fill="hold" nodeType="clickEffect">
+                                  <p:stCondLst>
+                                    <p:cond delay="0"/>
+                                  </p:stCondLst>
+                                  <p:childTnLst>
+                                    <p:set>
+                                      <p:cBhvr>
+                                        <p:cTn id="11" dur="1" fill="hold">
+                                          <p:stCondLst>
+                                            <p:cond delay="0"/>
+                                          </p:stCondLst>
+                                        </p:cTn>
+                                        <p:tgtEl>
+                                          <p:spTgt spid="3">
+                                            <p:txEl>
+                                              <p:pRg st="1" end="1"/>
+                                            </p:txEl>
+                                          </p:spTgt>
+                                        </p:tgtEl>
+                                        <p:attrNameLst>
+                                          <p:attrName>style.visibility</p:attrName>
+                                        </p:attrNameLst>
+                                      </p:cBhvr>
+                                      <p:to>
+                                        <p:strVal val="visible"/>
+                                      </p:to>
+                                    </p:set>
+                                    <p:animEffect transition="in" filter="fade">
+                                      <p:cBhvr>
+                                        <p:cTn id="12" dur="500"/>
+                                        <p:tgtEl>
+                                          <p:spTgt spid="3">
+                                            <p:txEl>
+                                              <p:pRg st="1" end="1"/>
+                                            </p:txEl>
+                                          </p:spTgt>
+                                        </p:tgtEl>
+                                      </p:cBhvr>
+                                    </p:animEffect>
+                                  </p:childTnLst>
+                                </p:cTn>
+                              </p:par>
+                            </p:childTnLst>
+                          </p:cTn>
+                        </p:par>
+                      </p:childTnLst>
+                    </p:cTn>
+                  </p:par>
+                  <p:par>
+                    <p:cTn id="13" fill="hold">
+                      <p:stCondLst>
+                        <p:cond delay="indefinite"/>
+                      </p:stCondLst>
+                      <p:childTnLst>
+                        <p:par>
+                          <p:cTn id="14" fill="hold">
+                            <p:stCondLst>
+                              <p:cond delay="0"/>
+                            </p:stCondLst>
+                            <p:childTnLst>
+                              <p:par>
+                                <p:cTn id="15" presetID="10" presetClass="entr" presetSubtype="0" fill="hold" nodeType="clickEffect">
+                                  <p:stCondLst>
+                                    <p:cond delay="0"/>
+                                  </p:stCondLst>
+                                  <p:childTnLst>
+                                    <p:set>
+                                      <p:cBhvr>
+                                        <p:cTn id="16" dur="1" fill="hold">
+                                          <p:stCondLst>
+                                            <p:cond delay="0"/>
+                                          </p:stCondLst>
+                                        </p:cTn>
+                                        <p:tgtEl>
+                                          <p:spTgt spid="3">
+                                            <p:txEl>
+                                              <p:pRg st="2" end="2"/>
+                                            </p:txEl>
+                                          </p:spTgt>
+                                        </p:tgtEl>
+                                        <p:attrNameLst>
+                                          <p:attrName>style.visibility</p:attrName>
+                                        </p:attrNameLst>
+                                      </p:cBhvr>
+                                      <p:to>
+                                        <p:strVal val="visible"/>
+                                      </p:to>
+                                    </p:set>
+                                    <p:animEffect transition="in" filter="fade">
+                                      <p:cBhvr>
+                                        <p:cTn id="17" dur="500"/>
+                                        <p:tgtEl>
+                                          <p:spTgt spid="3">
+                                            <p:txEl>
+                                              <p:pRg st="2" end="2"/>
+                                            </p:txEl>
+                                          </p:spTgt>
+                                        </p:tgtEl>
+                                      </p:cBhvr>
+                                    </p:animEffect>
+                                  </p:childTnLst>
+                                </p:cTn>
+                              </p:par>
+                            </p:childTnLst>
+                          </p:cTn>
+                        </p:par>
+                      </p:childTnLst>
+                    </p:cTn>
+                  </p:par>
+                  <p:par>
+                    <p:cTn id="18" fill="hold">
+                      <p:stCondLst>
+                        <p:cond delay="indefinite"/>
+                      </p:stCondLst>
+                      <p:childTnLst>
+                        <p:par>
+                          <p:cTn id="19" fill="hold">
+                            <p:stCondLst>
+                              <p:cond delay="0"/>
+                            </p:stCondLst>
+                            <p:childTnLst>
+                              <p:par>
+                                <p:cTn id="20" presetID="10" presetClass="entr" presetSubtype="0" fill="hold" nodeType="clickEffect">
+                                  <p:stCondLst>
+                                    <p:cond delay="0"/>
+                                  </p:stCondLst>
+                                  <p:childTnLst>
+                                    <p:set>
+                                      <p:cBhvr>
+                                        <p:cTn id="21" dur="1" fill="hold">
+                                          <p:stCondLst>
+                                            <p:cond delay="0"/>
+                                          </p:stCondLst>
+                                        </p:cTn>
+                                        <p:tgtEl>
+                                          <p:spTgt spid="3">
+                                            <p:txEl>
+                                              <p:pRg st="3" end="3"/>
+                                            </p:txEl>
+                                          </p:spTgt>
+                                        </p:tgtEl>
+                                        <p:attrNameLst>
+                                          <p:attrName>style.visibility</p:attrName>
+                                        </p:attrNameLst>
+                                      </p:cBhvr>
+                                      <p:to>
+                                        <p:strVal val="visible"/>
+                                      </p:to>
+                                    </p:set>
+                                    <p:animEffect transition="in" filter="fade">
+                                      <p:cBhvr>
+                                        <p:cTn id="22" dur="500"/>
+                                        <p:tgtEl>
+                                          <p:spTgt spid="3">
+                                            <p:txEl>
+                                              <p:pRg st="3" end="3"/>
+                                            </p:txEl>
+                                          </p:spTgt>
+                                        </p:tgtEl>
+                                      </p:cBhvr>
+                                    </p:animEffect>
+                                  </p:childTnLst>
+                                </p:cTn>
+                              </p:par>
+                            </p:childTnLst>
+                          </p:cTn>
+                        </p:par>
+                      </p:childTnLst>
+                    </p:cTn>
+                  </p:par>
+                  <p:par>
+                    <p:cTn id="23" fill="hold">
+                      <p:stCondLst>
+                        <p:cond delay="indefinite"/>
+                      </p:stCondLst>
+                      <p:childTnLst>
+                        <p:par>
+                          <p:cTn id="24" fill="hold">
+                            <p:stCondLst>
+                              <p:cond delay="0"/>
+                            </p:stCondLst>
+                            <p:childTnLst>
+                              <p:par>
+                                <p:cTn id="25" presetID="10" presetClass="entr" presetSubtype="0" fill="hold" nodeType="clickEffect">
+                                  <p:stCondLst>
+                                    <p:cond delay="0"/>
+                                  </p:stCondLst>
+                                  <p:childTnLst>
+                                    <p:set>
+                                      <p:cBhvr>
+                                        <p:cTn id="26" dur="1" fill="hold">
+                                          <p:stCondLst>
+                                            <p:cond delay="0"/>
+                                          </p:stCondLst>
+                                        </p:cTn>
+                                        <p:tgtEl>
+                                          <p:spTgt spid="3">
+                                            <p:txEl>
+                                              <p:pRg st="4" end="4"/>
+                                            </p:txEl>
+                                          </p:spTgt>
+                                        </p:tgtEl>
+                                        <p:attrNameLst>
+                                          <p:attrName>style.visibility</p:attrName>
+                                        </p:attrNameLst>
+                                      </p:cBhvr>
+                                      <p:to>
+                                        <p:strVal val="visible"/>
+                                      </p:to>
+                                    </p:set>
+                                    <p:animEffect transition="in" filter="fade">
+                                      <p:cBhvr>
+                                        <p:cTn id="27" dur="500"/>
+                                        <p:tgtEl>
+                                          <p:spTgt spid="3">
+                                            <p:txEl>
+                                              <p:pRg st="4" end="4"/>
+                                            </p:txEl>
+                                          </p:spTgt>
+                                        </p:tgtEl>
+                                      </p:cBhvr>
+                                    </p:animEffect>
+                                  </p:childTnLst>
+                                </p:cTn>
+                              </p:par>
+                            </p:childTnLst>
+                          </p:cTn>
+                        </p:par>
+                      </p:childTnLst>
+                    </p:cTn>
+                  </p:par>
+                  <p:par>
+                    <p:cTn id="28" fill="hold">
+                      <p:stCondLst>
+                        <p:cond delay="indefinite"/>
+                      </p:stCondLst>
+                      <p:childTnLst>
+                        <p:par>
+                          <p:cTn id="29" fill="hold">
+                            <p:stCondLst>
+                              <p:cond delay="0"/>
+                            </p:stCondLst>
+                            <p:childTnLst>
+                              <p:par>
+                                <p:cTn id="30" presetID="10" presetClass="entr" presetSubtype="0" fill="hold" nodeType="clickEffect">
+                                  <p:stCondLst>
+                                    <p:cond delay="0"/>
+                                  </p:stCondLst>
+                                  <p:childTnLst>
+                                    <p:set>
+                                      <p:cBhvr>
+                                        <p:cTn id="31" dur="1" fill="hold">
+                                          <p:stCondLst>
+                                            <p:cond delay="0"/>
+                                          </p:stCondLst>
+                                        </p:cTn>
+                                        <p:tgtEl>
+                                          <p:spTgt spid="3">
+                                            <p:txEl>
+                                              <p:pRg st="5" end="5"/>
+                                            </p:txEl>
+                                          </p:spTgt>
+                                        </p:tgtEl>
+                                        <p:attrNameLst>
+                                          <p:attrName>style.visibility</p:attrName>
+                                        </p:attrNameLst>
+                                      </p:cBhvr>
+                                      <p:to>
+                                        <p:strVal val="visible"/>
+                                      </p:to>
+                                    </p:set>
+                                    <p:animEffect transition="in" filter="fade">
+                                      <p:cBhvr>
+                                        <p:cTn id="32" dur="500"/>
+                                        <p:tgtEl>
+                                          <p:spTgt spid="3">
+                                            <p:txEl>
+                                              <p:pRg st="5" end="5"/>
+                                            </p:txEl>
+                                          </p:spTgt>
+                                        </p:tgtEl>
+                                      </p:cBhvr>
+                                    </p:animEffect>
+                                  </p:childTnLst>
+                                </p:cTn>
+                              </p:par>
+                            </p:childTnLst>
+                          </p:cTn>
+                        </p:par>
+                      </p:childTnLst>
+                    </p:cTn>
+                  </p:par>
+                  <p:par>
+                    <p:cTn id="33" fill="hold">
+                      <p:stCondLst>
+                        <p:cond delay="indefinite"/>
+                      </p:stCondLst>
+                      <p:childTnLst>
+                        <p:par>
+                          <p:cTn id="34" fill="hold">
+                            <p:stCondLst>
+                              <p:cond delay="0"/>
+                            </p:stCondLst>
+                            <p:childTnLst>
+                              <p:par>
+                                <p:cTn id="35" presetID="10" presetClass="entr" presetSubtype="0" fill="hold" nodeType="clickEffect">
+                                  <p:stCondLst>
+                                    <p:cond delay="0"/>
+                                  </p:stCondLst>
+                                  <p:childTnLst>
+                                    <p:set>
+                                      <p:cBhvr>
+                                        <p:cTn id="36" dur="1" fill="hold">
+                                          <p:stCondLst>
+                                            <p:cond delay="0"/>
+                                          </p:stCondLst>
+                                        </p:cTn>
+                                        <p:tgtEl>
+                                          <p:spTgt spid="3">
+                                            <p:txEl>
+                                              <p:pRg st="6" end="6"/>
+                                            </p:txEl>
+                                          </p:spTgt>
+                                        </p:tgtEl>
+                                        <p:attrNameLst>
+                                          <p:attrName>style.visibility</p:attrName>
+                                        </p:attrNameLst>
+                                      </p:cBhvr>
+                                      <p:to>
+                                        <p:strVal val="visible"/>
+                                      </p:to>
+                                    </p:set>
+                                    <p:animEffect transition="in" filter="fade">
+                                      <p:cBhvr>
+                                        <p:cTn id="37" dur="500"/>
+                                        <p:tgtEl>
+                                          <p:spTgt spid="3">
+                                            <p:txEl>
+                                              <p:pRg st="6" end="6"/>
+                                            </p:txEl>
+                                          </p:spTgt>
+                                        </p:tgtEl>
+                                      </p:cBhvr>
+                                    </p:animEffect>
+                                  </p:childTnLst>
+                                </p:cTn>
+                              </p:par>
+                            </p:childTnLst>
+                          </p:cTn>
+                        </p:par>
+                      </p:childTnLst>
+                    </p:cTn>
+                  </p:par>
+                </p:childTnLst>
+              </p:cTn>
+              <p:prevCondLst>
+                <p:cond evt="onPrev" delay="0">
+                  <p:tgtEl>
+                    <p:sldTgt/>
+                  </p:tgtEl>
+                </p:cond>
+              </p:prevCondLst>
+              <p:nextCondLst>
+                <p:cond evt="onNext" delay="0">
+                  <p:tgtEl>
+                    <p:sldTgt/>
+                  </p:tgtEl>
+                </p:cond>
+              </p:nextCondLst>
+            </p:seq>
+          </p:childTnLst>
+        </p:cTn>
+      </p:par>
+    </p:tnLst>
+  </p:timing>
 </p:sld>
 </file>
 

</xml_diff>